<commit_message>
Revamp viva PPT generator: premium diagrams and navy-teal theme
Rewrite generate_major_project_viva_ppt.py with infographic-style figures
per slide (architecture, monitoring, AWS, XAI, API auth, challenges).
Regenerate CardioSense_Major_Project_Viva.pptx from the updated pipeline.

Co-authored-by: Cursor <cursoragent@cursor.com>
</commit_message>
<xml_diff>
--- a/presentations/CardioSense_Major_Project_Viva.pptx
+++ b/presentations/CardioSense_Major_Project_Viva.pptx
@@ -3111,7 +3111,7 @@
       <p:grpSpPr/>
       <p:pic>
         <p:nvPicPr>
-          <p:cNvPr id="2" name="Picture 1" descr="tmpa080uf81.png"/>
+          <p:cNvPr id="2" name="Picture 1" descr="tmpr58hp2ua.png"/>
           <p:cNvPicPr>
             <a:picLocks noChangeAspect="1"/>
           </p:cNvPicPr>
@@ -3126,7 +3126,7 @@
         <p:spPr>
           <a:xfrm>
             <a:off x="0" y="0"/>
-            <a:ext cx="12191999" cy="7003914"/>
+            <a:ext cx="12191999" cy="7035680"/>
           </a:xfrm>
           <a:prstGeom prst="rect">
             <a:avLst/>
@@ -3178,14 +3178,57 @@
       </p:sp>
       <p:sp>
         <p:nvSpPr>
-          <p:cNvPr id="4" name="TextBox 3"/>
+          <p:cNvPr id="4" name="Rectangle 3"/>
+          <p:cNvSpPr/>
+          <p:nvPr/>
+        </p:nvSpPr>
+        <p:spPr>
+          <a:xfrm>
+            <a:off x="822960" y="1024128"/>
+            <a:ext cx="10515600" cy="82296"/>
+          </a:xfrm>
+          <a:prstGeom prst="rect">
+            <a:avLst/>
+          </a:prstGeom>
+          <a:solidFill>
+            <a:srgbClr val="2A9D8F"/>
+          </a:solidFill>
+          <a:ln>
+            <a:noFill/>
+          </a:ln>
+        </p:spPr>
+        <p:style>
+          <a:lnRef idx="1">
+            <a:schemeClr val="accent1"/>
+          </a:lnRef>
+          <a:fillRef idx="3">
+            <a:schemeClr val="accent1"/>
+          </a:fillRef>
+          <a:effectRef idx="2">
+            <a:schemeClr val="accent1"/>
+          </a:effectRef>
+          <a:fontRef idx="minor">
+            <a:schemeClr val="lt1"/>
+          </a:fontRef>
+        </p:style>
+        <p:txBody>
+          <a:bodyPr rtlCol="0" anchor="ctr"/>
+          <a:lstStyle/>
+          <a:p>
+            <a:pPr algn="ctr"/>
+          </a:p>
+        </p:txBody>
+      </p:sp>
+      <p:sp>
+        <p:nvSpPr>
+          <p:cNvPr id="5" name="TextBox 4"/>
           <p:cNvSpPr txBox="1"/>
           <p:nvPr/>
         </p:nvSpPr>
         <p:spPr>
           <a:xfrm>
-            <a:off x="822960" y="1234440"/>
-            <a:ext cx="10515600" cy="2194560"/>
+            <a:off x="777240" y="1234440"/>
+            <a:ext cx="10607040" cy="2331720"/>
           </a:xfrm>
           <a:prstGeom prst="rect">
             <a:avLst/>
@@ -3200,7 +3243,7 @@
           <a:p>
             <a:pPr algn="ctr"/>
             <a:r>
-              <a:rPr sz="2600" b="1">
+              <a:rPr sz="2800" b="1">
                 <a:solidFill>
                   <a:srgbClr val="FFFFFF"/>
                 </a:solidFill>
@@ -3221,14 +3264,49 @@
       </p:sp>
       <p:sp>
         <p:nvSpPr>
-          <p:cNvPr id="5" name="TextBox 4"/>
+          <p:cNvPr id="6" name="TextBox 5"/>
           <p:cNvSpPr txBox="1"/>
           <p:nvPr/>
         </p:nvSpPr>
         <p:spPr>
           <a:xfrm>
-            <a:off x="914400" y="3703320"/>
-            <a:ext cx="10058400" cy="2651760"/>
+            <a:off x="914400" y="3639312"/>
+            <a:ext cx="10241280" cy="365760"/>
+          </a:xfrm>
+          <a:prstGeom prst="rect">
+            <a:avLst/>
+          </a:prstGeom>
+          <a:noFill/>
+        </p:spPr>
+        <p:txBody>
+          <a:bodyPr wrap="none">
+            <a:spAutoFit/>
+          </a:bodyPr>
+          <a:lstStyle/>
+          <a:p>
+            <a:pPr algn="ctr"/>
+            <a:r>
+              <a:rPr sz="1200" b="0">
+                <a:solidFill>
+                  <a:srgbClr val="B4DCD7"/>
+                </a:solidFill>
+                <a:latin typeface="Calibri"/>
+              </a:rPr>
+              <a:t>CardioSense · Clinical decision support platform (production-style stack)</a:t>
+            </a:r>
+          </a:p>
+        </p:txBody>
+      </p:sp>
+      <p:sp>
+        <p:nvSpPr>
+          <p:cNvPr id="7" name="TextBox 6"/>
+          <p:cNvSpPr txBox="1"/>
+          <p:nvPr/>
+        </p:nvSpPr>
+        <p:spPr>
+          <a:xfrm>
+            <a:off x="914400" y="4069080"/>
+            <a:ext cx="10058400" cy="2606040"/>
           </a:xfrm>
           <a:prstGeom prst="rect">
             <a:avLst/>
@@ -3249,23 +3327,23 @@
             <a:r>
               <a:rPr sz="1300" b="1">
                 <a:solidFill>
-                  <a:srgbClr val="A8DADC"/>
+                  <a:srgbClr val="FFFFFF"/>
                 </a:solidFill>
                 <a:latin typeface="Times New Roman"/>
               </a:rPr>
-              <a:t>Major Project · CardioSense (ecg-ami-cds codebase)</a:t>
+              <a:t>Major Project — ecg-ami-cds</a:t>
             </a:r>
           </a:p>
           <a:p>
             <a:pPr algn="ctr">
               <a:spcBef>
-                <a:spcPts val="1000"/>
+                <a:spcPts val="800"/>
               </a:spcBef>
             </a:pPr>
             <a:r>
               <a:rPr sz="1400" b="0">
                 <a:solidFill>
-                  <a:srgbClr val="C8D2E1"/>
+                  <a:srgbClr val="C6D0E0"/>
                 </a:solidFill>
                 <a:latin typeface="Times New Roman"/>
               </a:rPr>
@@ -3281,7 +3359,7 @@
             <a:r>
               <a:rPr sz="1400" b="0">
                 <a:solidFill>
-                  <a:srgbClr val="C8D2E1"/>
+                  <a:srgbClr val="C6D0E0"/>
                 </a:solidFill>
                 <a:latin typeface="Times New Roman"/>
               </a:rPr>
@@ -3297,7 +3375,7 @@
             <a:r>
               <a:rPr sz="1400" b="0">
                 <a:solidFill>
-                  <a:srgbClr val="C8D2E1"/>
+                  <a:srgbClr val="C6D0E0"/>
                 </a:solidFill>
                 <a:latin typeface="Times New Roman"/>
               </a:rPr>
@@ -3313,7 +3391,7 @@
             <a:r>
               <a:rPr sz="1400" b="0">
                 <a:solidFill>
-                  <a:srgbClr val="C8D2E1"/>
+                  <a:srgbClr val="C6D0E0"/>
                 </a:solidFill>
                 <a:latin typeface="Times New Roman"/>
               </a:rPr>
@@ -3350,14 +3428,57 @@
       <p:grpSpPr/>
       <p:sp>
         <p:nvSpPr>
-          <p:cNvPr id="2" name="TextBox 1"/>
+          <p:cNvPr id="2" name="Rectangle 1"/>
+          <p:cNvSpPr/>
+          <p:nvPr/>
+        </p:nvSpPr>
+        <p:spPr>
+          <a:xfrm>
+            <a:off x="0" y="347472"/>
+            <a:ext cx="12191999" cy="54864"/>
+          </a:xfrm>
+          <a:prstGeom prst="rect">
+            <a:avLst/>
+          </a:prstGeom>
+          <a:solidFill>
+            <a:srgbClr val="2A9D8F"/>
+          </a:solidFill>
+          <a:ln>
+            <a:noFill/>
+          </a:ln>
+        </p:spPr>
+        <p:style>
+          <a:lnRef idx="1">
+            <a:schemeClr val="accent1"/>
+          </a:lnRef>
+          <a:fillRef idx="3">
+            <a:schemeClr val="accent1"/>
+          </a:fillRef>
+          <a:effectRef idx="2">
+            <a:schemeClr val="accent1"/>
+          </a:effectRef>
+          <a:fontRef idx="minor">
+            <a:schemeClr val="lt1"/>
+          </a:fontRef>
+        </p:style>
+        <p:txBody>
+          <a:bodyPr rtlCol="0" anchor="ctr"/>
+          <a:lstStyle/>
+          <a:p>
+            <a:pPr algn="ctr"/>
+          </a:p>
+        </p:txBody>
+      </p:sp>
+      <p:sp>
+        <p:nvSpPr>
+          <p:cNvPr id="3" name="TextBox 2"/>
           <p:cNvSpPr txBox="1"/>
           <p:nvPr/>
         </p:nvSpPr>
         <p:spPr>
           <a:xfrm>
-            <a:off x="502920" y="320040"/>
-            <a:ext cx="10972800" cy="685800"/>
+            <a:off x="502920" y="475488"/>
+            <a:ext cx="11155680" cy="822960"/>
           </a:xfrm>
           <a:prstGeom prst="rect">
             <a:avLst/>
@@ -3371,7 +3492,7 @@
           <a:lstStyle/>
           <a:p>
             <a:r>
-              <a:rPr sz="2400" b="1">
+              <a:rPr sz="2800" b="1">
                 <a:solidFill>
                   <a:srgbClr val="FFFFFF"/>
                 </a:solidFill>
@@ -3382,9 +3503,43 @@
           </a:p>
         </p:txBody>
       </p:sp>
+      <p:sp>
+        <p:nvSpPr>
+          <p:cNvPr id="4" name="TextBox 3"/>
+          <p:cNvSpPr txBox="1"/>
+          <p:nvPr/>
+        </p:nvSpPr>
+        <p:spPr>
+          <a:xfrm>
+            <a:off x="548640" y="987552"/>
+            <a:ext cx="10972800" cy="411480"/>
+          </a:xfrm>
+          <a:prstGeom prst="rect">
+            <a:avLst/>
+          </a:prstGeom>
+          <a:noFill/>
+        </p:spPr>
+        <p:txBody>
+          <a:bodyPr wrap="none">
+            <a:spAutoFit/>
+          </a:bodyPr>
+          <a:lstStyle/>
+          <a:p>
+            <a:r>
+              <a:rPr sz="1200" b="0">
+                <a:solidFill>
+                  <a:srgbClr val="C6D0E0"/>
+                </a:solidFill>
+                <a:latin typeface="Calibri"/>
+              </a:rPr>
+              <a:t>Grafana-style time-series + Prometheus scrape chain reflecting backend/metrics.py instrumentation.</a:t>
+            </a:r>
+          </a:p>
+        </p:txBody>
+      </p:sp>
       <p:pic>
         <p:nvPicPr>
-          <p:cNvPr id="3" name="Picture 2" descr="tmp581ya06y.png"/>
+          <p:cNvPr id="5" name="Picture 4" descr="tmpi00mohfs.png"/>
           <p:cNvPicPr>
             <a:picLocks noChangeAspect="1"/>
           </p:cNvPicPr>
@@ -3398,48 +3553,14 @@
         </p:blipFill>
         <p:spPr>
           <a:xfrm>
-            <a:off x="594360" y="960120"/>
-            <a:ext cx="11064240" cy="5206280"/>
+            <a:off x="411480" y="1389888"/>
+            <a:ext cx="11384280" cy="5670517"/>
           </a:xfrm>
           <a:prstGeom prst="rect">
             <a:avLst/>
           </a:prstGeom>
         </p:spPr>
       </p:pic>
-      <p:sp>
-        <p:nvSpPr>
-          <p:cNvPr id="4" name="TextBox 3"/>
-          <p:cNvSpPr txBox="1"/>
-          <p:nvPr/>
-        </p:nvSpPr>
-        <p:spPr>
-          <a:xfrm>
-            <a:off x="594360" y="6263640"/>
-            <a:ext cx="10972800" cy="502920"/>
-          </a:xfrm>
-          <a:prstGeom prst="rect">
-            <a:avLst/>
-          </a:prstGeom>
-          <a:noFill/>
-        </p:spPr>
-        <p:txBody>
-          <a:bodyPr wrap="none">
-            <a:spAutoFit/>
-          </a:bodyPr>
-          <a:lstStyle/>
-          <a:p>
-            <a:r>
-              <a:rPr sz="1100" b="0">
-                <a:solidFill>
-                  <a:srgbClr val="C8D2E1"/>
-                </a:solidFill>
-                <a:latin typeface="Times New Roman"/>
-              </a:rPr>
-              <a:t>Series names illustrated above match prometheus_client instrumentation; dashboards provisioned from deploy/grafana/dashboards/.</a:t>
-            </a:r>
-          </a:p>
-        </p:txBody>
-      </p:sp>
     </p:spTree>
   </p:cSld>
   <p:clrMapOvr>
@@ -3468,14 +3589,57 @@
       <p:grpSpPr/>
       <p:sp>
         <p:nvSpPr>
-          <p:cNvPr id="2" name="TextBox 1"/>
+          <p:cNvPr id="2" name="Rectangle 1"/>
+          <p:cNvSpPr/>
+          <p:nvPr/>
+        </p:nvSpPr>
+        <p:spPr>
+          <a:xfrm>
+            <a:off x="0" y="347472"/>
+            <a:ext cx="12191999" cy="54864"/>
+          </a:xfrm>
+          <a:prstGeom prst="rect">
+            <a:avLst/>
+          </a:prstGeom>
+          <a:solidFill>
+            <a:srgbClr val="2A9D8F"/>
+          </a:solidFill>
+          <a:ln>
+            <a:noFill/>
+          </a:ln>
+        </p:spPr>
+        <p:style>
+          <a:lnRef idx="1">
+            <a:schemeClr val="accent1"/>
+          </a:lnRef>
+          <a:fillRef idx="3">
+            <a:schemeClr val="accent1"/>
+          </a:fillRef>
+          <a:effectRef idx="2">
+            <a:schemeClr val="accent1"/>
+          </a:effectRef>
+          <a:fontRef idx="minor">
+            <a:schemeClr val="lt1"/>
+          </a:fontRef>
+        </p:style>
+        <p:txBody>
+          <a:bodyPr rtlCol="0" anchor="ctr"/>
+          <a:lstStyle/>
+          <a:p>
+            <a:pPr algn="ctr"/>
+          </a:p>
+        </p:txBody>
+      </p:sp>
+      <p:sp>
+        <p:nvSpPr>
+          <p:cNvPr id="3" name="TextBox 2"/>
           <p:cNvSpPr txBox="1"/>
           <p:nvPr/>
         </p:nvSpPr>
         <p:spPr>
           <a:xfrm>
-            <a:off x="502920" y="320040"/>
-            <a:ext cx="10972800" cy="685800"/>
+            <a:off x="502920" y="475488"/>
+            <a:ext cx="11155680" cy="822960"/>
           </a:xfrm>
           <a:prstGeom prst="rect">
             <a:avLst/>
@@ -3489,20 +3653,54 @@
           <a:lstStyle/>
           <a:p>
             <a:r>
-              <a:rPr sz="2400" b="1">
+              <a:rPr sz="2800" b="1">
                 <a:solidFill>
                   <a:srgbClr val="FFFFFF"/>
                 </a:solidFill>
                 <a:latin typeface="Times New Roman"/>
               </a:rPr>
-              <a:t>AWS cloud deployment</a:t>
+              <a:t>AWS EC2 deployment — Docker &amp; nginx ingress</a:t>
+            </a:r>
+          </a:p>
+        </p:txBody>
+      </p:sp>
+      <p:sp>
+        <p:nvSpPr>
+          <p:cNvPr id="4" name="TextBox 3"/>
+          <p:cNvSpPr txBox="1"/>
+          <p:nvPr/>
+        </p:nvSpPr>
+        <p:spPr>
+          <a:xfrm>
+            <a:off x="548640" y="987552"/>
+            <a:ext cx="10972800" cy="411480"/>
+          </a:xfrm>
+          <a:prstGeom prst="rect">
+            <a:avLst/>
+          </a:prstGeom>
+          <a:noFill/>
+        </p:spPr>
+        <p:txBody>
+          <a:bodyPr wrap="none">
+            <a:spAutoFit/>
+          </a:bodyPr>
+          <a:lstStyle/>
+          <a:p>
+            <a:r>
+              <a:rPr sz="1200" b="0">
+                <a:solidFill>
+                  <a:srgbClr val="C6D0E0"/>
+                </a:solidFill>
+                <a:latin typeface="Calibri"/>
+              </a:rPr>
+              <a:t>Light theme cloud diagram · maps to docker-compose.production.yml + EC2 host nginx TLS.</a:t>
             </a:r>
           </a:p>
         </p:txBody>
       </p:sp>
       <p:pic>
         <p:nvPicPr>
-          <p:cNvPr id="3" name="Picture 2" descr="tmpt04_kxw1.png"/>
+          <p:cNvPr id="5" name="Picture 4" descr="tmpyyodt8g6.png"/>
           <p:cNvPicPr>
             <a:picLocks noChangeAspect="1"/>
           </p:cNvPicPr>
@@ -3516,48 +3714,14 @@
         </p:blipFill>
         <p:spPr>
           <a:xfrm>
-            <a:off x="594360" y="960120"/>
-            <a:ext cx="11064240" cy="4917440"/>
+            <a:off x="411480" y="1389888"/>
+            <a:ext cx="11384280" cy="5472245"/>
           </a:xfrm>
           <a:prstGeom prst="rect">
             <a:avLst/>
           </a:prstGeom>
         </p:spPr>
       </p:pic>
-      <p:sp>
-        <p:nvSpPr>
-          <p:cNvPr id="4" name="TextBox 3"/>
-          <p:cNvSpPr txBox="1"/>
-          <p:nvPr/>
-        </p:nvSpPr>
-        <p:spPr>
-          <a:xfrm>
-            <a:off x="594360" y="6263640"/>
-            <a:ext cx="10972800" cy="502920"/>
-          </a:xfrm>
-          <a:prstGeom prst="rect">
-            <a:avLst/>
-          </a:prstGeom>
-          <a:noFill/>
-        </p:spPr>
-        <p:txBody>
-          <a:bodyPr wrap="none">
-            <a:spAutoFit/>
-          </a:bodyPr>
-          <a:lstStyle/>
-          <a:p>
-            <a:r>
-              <a:rPr sz="1100" b="0">
-                <a:solidFill>
-                  <a:srgbClr val="C8D2E1"/>
-                </a:solidFill>
-                <a:latin typeface="Times New Roman"/>
-              </a:rPr>
-              <a:t>Production Compose binds backend·frontend·Prometheus·Grafana to 127.0.0.1; TLS termination via host nginx configuration.</a:t>
-            </a:r>
-          </a:p>
-        </p:txBody>
-      </p:sp>
     </p:spTree>
   </p:cSld>
   <p:clrMapOvr>
@@ -3586,14 +3750,57 @@
       <p:grpSpPr/>
       <p:sp>
         <p:nvSpPr>
-          <p:cNvPr id="2" name="TextBox 1"/>
+          <p:cNvPr id="2" name="Rectangle 1"/>
+          <p:cNvSpPr/>
+          <p:nvPr/>
+        </p:nvSpPr>
+        <p:spPr>
+          <a:xfrm>
+            <a:off x="0" y="347472"/>
+            <a:ext cx="12191999" cy="54864"/>
+          </a:xfrm>
+          <a:prstGeom prst="rect">
+            <a:avLst/>
+          </a:prstGeom>
+          <a:solidFill>
+            <a:srgbClr val="2A9D8F"/>
+          </a:solidFill>
+          <a:ln>
+            <a:noFill/>
+          </a:ln>
+        </p:spPr>
+        <p:style>
+          <a:lnRef idx="1">
+            <a:schemeClr val="accent1"/>
+          </a:lnRef>
+          <a:fillRef idx="3">
+            <a:schemeClr val="accent1"/>
+          </a:fillRef>
+          <a:effectRef idx="2">
+            <a:schemeClr val="accent1"/>
+          </a:effectRef>
+          <a:fontRef idx="minor">
+            <a:schemeClr val="lt1"/>
+          </a:fontRef>
+        </p:style>
+        <p:txBody>
+          <a:bodyPr rtlCol="0" anchor="ctr"/>
+          <a:lstStyle/>
+          <a:p>
+            <a:pPr algn="ctr"/>
+          </a:p>
+        </p:txBody>
+      </p:sp>
+      <p:sp>
+        <p:nvSpPr>
+          <p:cNvPr id="3" name="TextBox 2"/>
           <p:cNvSpPr txBox="1"/>
           <p:nvPr/>
         </p:nvSpPr>
         <p:spPr>
           <a:xfrm>
-            <a:off x="502920" y="411480"/>
-            <a:ext cx="10972800" cy="777240"/>
+            <a:off x="502920" y="475488"/>
+            <a:ext cx="11155680" cy="822960"/>
           </a:xfrm>
           <a:prstGeom prst="rect">
             <a:avLst/>
@@ -3607,319 +3814,75 @@
           <a:lstStyle/>
           <a:p>
             <a:r>
-              <a:rPr sz="2600" b="1">
+              <a:rPr sz="2800" b="1">
                 <a:solidFill>
                   <a:srgbClr val="FFFFFF"/>
                 </a:solidFill>
                 <a:latin typeface="Times New Roman"/>
               </a:rPr>
-              <a:t>Results &amp; outputs (no fabricated cohort metrics)</a:t>
-            </a:r>
-          </a:p>
-        </p:txBody>
-      </p:sp>
-      <p:graphicFrame>
-        <p:nvGraphicFramePr>
-          <p:cNvPr id="3" name="Table 2"/>
-          <p:cNvGraphicFramePr>
-            <a:graphicFrameLocks noGrp="1"/>
-          </p:cNvGraphicFramePr>
+              <a:t>Results, KPIs &amp; evidence slots</a:t>
+            </a:r>
+          </a:p>
+        </p:txBody>
+      </p:sp>
+      <p:sp>
+        <p:nvSpPr>
+          <p:cNvPr id="4" name="TextBox 3"/>
+          <p:cNvSpPr txBox="1"/>
           <p:nvPr/>
-        </p:nvGraphicFramePr>
-        <p:xfrm>
-          <a:off x="822960" y="1234440"/>
-          <a:ext cx="10515600" cy="2304288"/>
-        </p:xfrm>
-        <a:graphic>
-          <a:graphicData uri="http://schemas.openxmlformats.org/drawingml/2006/table">
-            <a:tbl>
-              <a:tblPr firstRow="1" bandRow="1">
-                <a:tableStyleId>{5C22544A-7EE6-4342-B048-85BDC9FD1C3A}</a:tableStyleId>
-              </a:tblPr>
-              <a:tblGrid>
-                <a:gridCol w="5257800"/>
-                <a:gridCol w="5257800"/>
-              </a:tblGrid>
-              <a:tr h="384048">
-                <a:tc>
-                  <a:txBody>
-                    <a:bodyPr/>
-                    <a:lstStyle/>
-                    <a:p>
-                      <a:r>
-                        <a:rPr sz="1300" b="1">
-                          <a:solidFill>
-                            <a:srgbClr val="FFFFFF"/>
-                          </a:solidFill>
-                          <a:latin typeface="Times New Roman"/>
-                        </a:rPr>
-                        <a:t>Deliverable</a:t>
-                      </a:r>
-                    </a:p>
-                  </a:txBody>
-                  <a:tcPr>
-                    <a:solidFill>
-                      <a:srgbClr val="1B263B"/>
-                    </a:solidFill>
-                  </a:tcPr>
-                </a:tc>
-                <a:tc>
-                  <a:txBody>
-                    <a:bodyPr/>
-                    <a:lstStyle/>
-                    <a:p>
-                      <a:r>
-                        <a:rPr sz="1300" b="1">
-                          <a:solidFill>
-                            <a:srgbClr val="FFFFFF"/>
-                          </a:solidFill>
-                          <a:latin typeface="Times New Roman"/>
-                        </a:rPr>
-                        <a:t>What the deployed stack exposes</a:t>
-                      </a:r>
-                    </a:p>
-                  </a:txBody>
-                  <a:tcPr>
-                    <a:solidFill>
-                      <a:srgbClr val="1B263B"/>
-                    </a:solidFill>
-                  </a:tcPr>
-                </a:tc>
-              </a:tr>
-              <a:tr h="384048">
-                <a:tc>
-                  <a:txBody>
-                    <a:bodyPr/>
-                    <a:lstStyle/>
-                    <a:p>
-                      <a:r>
-                        <a:rPr sz="1300" b="0">
-                          <a:solidFill>
-                            <a:srgbClr val="C8D2E1"/>
-                          </a:solidFill>
-                          <a:latin typeface="Times New Roman"/>
-                        </a:rPr>
-                        <a:t>Classification outputs</a:t>
-                      </a:r>
-                    </a:p>
-                  </a:txBody>
-                  <a:tcPr>
-                    <a:solidFill>
-                      <a:srgbClr val="0D1B2A"/>
-                    </a:solidFill>
-                  </a:tcPr>
-                </a:tc>
-                <a:tc>
-                  <a:txBody>
-                    <a:bodyPr/>
-                    <a:lstStyle/>
-                    <a:p>
-                      <a:r>
-                        <a:rPr sz="1300" b="0">
-                          <a:solidFill>
-                            <a:srgbClr val="C8D2E1"/>
-                          </a:solidFill>
-                          <a:latin typeface="Times New Roman"/>
-                        </a:rPr>
-                        <a:t>AMI probability · revascularization probability · urgency tiering logic</a:t>
-                      </a:r>
-                    </a:p>
-                  </a:txBody>
-                  <a:tcPr>
-                    <a:solidFill>
-                      <a:srgbClr val="0D1B2A"/>
-                    </a:solidFill>
-                  </a:tcPr>
-                </a:tc>
-              </a:tr>
-              <a:tr h="384048">
-                <a:tc>
-                  <a:txBody>
-                    <a:bodyPr/>
-                    <a:lstStyle/>
-                    <a:p>
-                      <a:r>
-                        <a:rPr sz="1300" b="0">
-                          <a:solidFill>
-                            <a:srgbClr val="C8D2E1"/>
-                          </a:solidFill>
-                          <a:latin typeface="Times New Roman"/>
-                        </a:rPr>
-                        <a:t>XAI artefacts</a:t>
-                      </a:r>
-                    </a:p>
-                  </a:txBody>
-                  <a:tcPr>
-                    <a:solidFill>
-                      <a:srgbClr val="0D1B2A"/>
-                    </a:solidFill>
-                  </a:tcPr>
-                </a:tc>
-                <a:tc>
-                  <a:txBody>
-                    <a:bodyPr/>
-                    <a:lstStyle/>
-                    <a:p>
-                      <a:r>
-                        <a:rPr sz="1300" b="0">
-                          <a:solidFill>
-                            <a:srgbClr val="C8D2E1"/>
-                          </a:solidFill>
-                          <a:latin typeface="Times New Roman"/>
-                        </a:rPr>
-                        <a:t>gradcam_lead_importance · shap_features JSON mirrored in SQLite Prediction rows</a:t>
-                      </a:r>
-                    </a:p>
-                  </a:txBody>
-                  <a:tcPr>
-                    <a:solidFill>
-                      <a:srgbClr val="0D1B2A"/>
-                    </a:solidFill>
-                  </a:tcPr>
-                </a:tc>
-              </a:tr>
-              <a:tr h="384048">
-                <a:tc>
-                  <a:txBody>
-                    <a:bodyPr/>
-                    <a:lstStyle/>
-                    <a:p>
-                      <a:r>
-                        <a:rPr sz="1300" b="0">
-                          <a:solidFill>
-                            <a:srgbClr val="C8D2E1"/>
-                          </a:solidFill>
-                          <a:latin typeface="Times New Roman"/>
-                        </a:rPr>
-                        <a:t>Operational signals</a:t>
-                      </a:r>
-                    </a:p>
-                  </a:txBody>
-                  <a:tcPr>
-                    <a:solidFill>
-                      <a:srgbClr val="0D1B2A"/>
-                    </a:solidFill>
-                  </a:tcPr>
-                </a:tc>
-                <a:tc>
-                  <a:txBody>
-                    <a:bodyPr/>
-                    <a:lstStyle/>
-                    <a:p>
-                      <a:r>
-                        <a:rPr sz="1300" b="0">
-                          <a:solidFill>
-                            <a:srgbClr val="C8D2E1"/>
-                          </a:solidFill>
-                          <a:latin typeface="Times New Roman"/>
-                        </a:rPr>
-                        <a:t>Predict latency histogram · AMI risk-tier counters · optional TP/TN/FP/FN when ami_ground_truth supplied</a:t>
-                      </a:r>
-                    </a:p>
-                  </a:txBody>
-                  <a:tcPr>
-                    <a:solidFill>
-                      <a:srgbClr val="0D1B2A"/>
-                    </a:solidFill>
-                  </a:tcPr>
-                </a:tc>
-              </a:tr>
-              <a:tr h="384048">
-                <a:tc>
-                  <a:txBody>
-                    <a:bodyPr/>
-                    <a:lstStyle/>
-                    <a:p>
-                      <a:r>
-                        <a:rPr sz="1300" b="0">
-                          <a:solidFill>
-                            <a:srgbClr val="C8D2E1"/>
-                          </a:solidFill>
-                          <a:latin typeface="Times New Roman"/>
-                        </a:rPr>
-                        <a:t>Formal KPI table</a:t>
-                      </a:r>
-                    </a:p>
-                  </a:txBody>
-                  <a:tcPr>
-                    <a:solidFill>
-                      <a:srgbClr val="0D1B2A"/>
-                    </a:solidFill>
-                  </a:tcPr>
-                </a:tc>
-                <a:tc>
-                  <a:txBody>
-                    <a:bodyPr/>
-                    <a:lstStyle/>
-                    <a:p>
-                      <a:r>
-                        <a:rPr sz="1300" b="0">
-                          <a:solidFill>
-                            <a:srgbClr val="C8D2E1"/>
-                          </a:solidFill>
-                          <a:latin typeface="Times New Roman"/>
-                        </a:rPr>
-                        <a:t>Populate AUROC / Sens / Spec from thesis validation chapter — not hard-coded in repo</a:t>
-                      </a:r>
-                    </a:p>
-                  </a:txBody>
-                  <a:tcPr>
-                    <a:solidFill>
-                      <a:srgbClr val="0D1B2A"/>
-                    </a:solidFill>
-                  </a:tcPr>
-                </a:tc>
-              </a:tr>
-              <a:tr h="384048">
-                <a:tc>
-                  <a:txBody>
-                    <a:bodyPr/>
-                    <a:lstStyle/>
-                    <a:p>
-                      <a:r>
-                        <a:rPr sz="1300" b="0">
-                          <a:solidFill>
-                            <a:srgbClr val="C8D2E1"/>
-                          </a:solidFill>
-                          <a:latin typeface="Times New Roman"/>
-                        </a:rPr>
-                        <a:t>UI evidence</a:t>
-                      </a:r>
-                    </a:p>
-                  </a:txBody>
-                  <a:tcPr>
-                    <a:solidFill>
-                      <a:srgbClr val="0D1B2A"/>
-                    </a:solidFill>
-                  </a:tcPr>
-                </a:tc>
-                <a:tc>
-                  <a:txBody>
-                    <a:bodyPr/>
-                    <a:lstStyle/>
-                    <a:p>
-                      <a:r>
-                        <a:rPr sz="1300" b="0">
-                          <a:solidFill>
-                            <a:srgbClr val="C8D2E1"/>
-                          </a:solidFill>
-                          <a:latin typeface="Times New Roman"/>
-                        </a:rPr>
-                        <a:t>Screenshots from Next.js analyse · explain · alerts routes for viva appendix</a:t>
-                      </a:r>
-                    </a:p>
-                  </a:txBody>
-                  <a:tcPr>
-                    <a:solidFill>
-                      <a:srgbClr val="0D1B2A"/>
-                    </a:solidFill>
-                  </a:tcPr>
-                </a:tc>
-              </a:tr>
-            </a:tbl>
-          </a:graphicData>
-        </a:graphic>
-      </p:graphicFrame>
+        </p:nvSpPr>
+        <p:spPr>
+          <a:xfrm>
+            <a:off x="548640" y="987552"/>
+            <a:ext cx="10972800" cy="411480"/>
+          </a:xfrm>
+          <a:prstGeom prst="rect">
+            <a:avLst/>
+          </a:prstGeom>
+          <a:noFill/>
+        </p:spPr>
+        <p:txBody>
+          <a:bodyPr wrap="none">
+            <a:spAutoFit/>
+          </a:bodyPr>
+          <a:lstStyle/>
+          <a:p>
+            <a:r>
+              <a:rPr sz="1200" b="0">
+                <a:solidFill>
+                  <a:srgbClr val="C6D0E0"/>
+                </a:solidFill>
+                <a:latin typeface="Calibri"/>
+              </a:rPr>
+              <a:t>Placeholders for thesis metrics + replace wireframes with your capture of the live UI and Grafana.</a:t>
+            </a:r>
+          </a:p>
+        </p:txBody>
+      </p:sp>
+      <p:pic>
+        <p:nvPicPr>
+          <p:cNvPr id="5" name="Picture 4" descr="tmp7wwmmzie.png"/>
+          <p:cNvPicPr>
+            <a:picLocks noChangeAspect="1"/>
+          </p:cNvPicPr>
+          <p:nvPr/>
+        </p:nvPicPr>
+        <p:blipFill>
+          <a:blip r:embed="rId2"/>
+          <a:stretch>
+            <a:fillRect/>
+          </a:stretch>
+        </p:blipFill>
+        <p:spPr>
+          <a:xfrm>
+            <a:off x="411480" y="1389888"/>
+            <a:ext cx="11384280" cy="5509574"/>
+          </a:xfrm>
+          <a:prstGeom prst="rect">
+            <a:avLst/>
+          </a:prstGeom>
+        </p:spPr>
+      </p:pic>
     </p:spTree>
   </p:cSld>
   <p:clrMapOvr>
@@ -3948,14 +3911,57 @@
       <p:grpSpPr/>
       <p:sp>
         <p:nvSpPr>
-          <p:cNvPr id="2" name="TextBox 1"/>
+          <p:cNvPr id="2" name="Rectangle 1"/>
+          <p:cNvSpPr/>
+          <p:nvPr/>
+        </p:nvSpPr>
+        <p:spPr>
+          <a:xfrm>
+            <a:off x="0" y="347472"/>
+            <a:ext cx="12191999" cy="54864"/>
+          </a:xfrm>
+          <a:prstGeom prst="rect">
+            <a:avLst/>
+          </a:prstGeom>
+          <a:solidFill>
+            <a:srgbClr val="2A9D8F"/>
+          </a:solidFill>
+          <a:ln>
+            <a:noFill/>
+          </a:ln>
+        </p:spPr>
+        <p:style>
+          <a:lnRef idx="1">
+            <a:schemeClr val="accent1"/>
+          </a:lnRef>
+          <a:fillRef idx="3">
+            <a:schemeClr val="accent1"/>
+          </a:fillRef>
+          <a:effectRef idx="2">
+            <a:schemeClr val="accent1"/>
+          </a:effectRef>
+          <a:fontRef idx="minor">
+            <a:schemeClr val="lt1"/>
+          </a:fontRef>
+        </p:style>
+        <p:txBody>
+          <a:bodyPr rtlCol="0" anchor="ctr"/>
+          <a:lstStyle/>
+          <a:p>
+            <a:pPr algn="ctr"/>
+          </a:p>
+        </p:txBody>
+      </p:sp>
+      <p:sp>
+        <p:nvSpPr>
+          <p:cNvPr id="3" name="TextBox 2"/>
           <p:cNvSpPr txBox="1"/>
           <p:nvPr/>
         </p:nvSpPr>
         <p:spPr>
           <a:xfrm>
-            <a:off x="502920" y="411480"/>
-            <a:ext cx="10972800" cy="777240"/>
+            <a:off x="502920" y="475488"/>
+            <a:ext cx="11155680" cy="822960"/>
           </a:xfrm>
           <a:prstGeom prst="rect">
             <a:avLst/>
@@ -3969,27 +3975,27 @@
           <a:lstStyle/>
           <a:p>
             <a:r>
-              <a:rPr sz="2600" b="1">
+              <a:rPr sz="2800" b="1">
                 <a:solidFill>
                   <a:srgbClr val="FFFFFF"/>
                 </a:solidFill>
                 <a:latin typeface="Times New Roman"/>
               </a:rPr>
-              <a:t>Challenges faced (engineering)</a:t>
-            </a:r>
-          </a:p>
-        </p:txBody>
-      </p:sp>
-      <p:sp>
-        <p:nvSpPr>
-          <p:cNvPr id="3" name="TextBox 2"/>
+              <a:t>Engineering challenges</a:t>
+            </a:r>
+          </a:p>
+        </p:txBody>
+      </p:sp>
+      <p:sp>
+        <p:nvSpPr>
+          <p:cNvPr id="4" name="TextBox 3"/>
           <p:cNvSpPr txBox="1"/>
           <p:nvPr/>
         </p:nvSpPr>
         <p:spPr>
           <a:xfrm>
-            <a:off x="685800" y="1234440"/>
-            <a:ext cx="10789920" cy="5394960"/>
+            <a:off x="548640" y="987552"/>
+            <a:ext cx="10972800" cy="411480"/>
           </a:xfrm>
           <a:prstGeom prst="rect">
             <a:avLst/>
@@ -3997,108 +4003,47 @@
           <a:noFill/>
         </p:spPr>
         <p:txBody>
-          <a:bodyPr wrap="square">
+          <a:bodyPr wrap="none">
             <a:spAutoFit/>
           </a:bodyPr>
           <a:lstStyle/>
           <a:p>
-            <a:pPr>
-              <a:spcAft>
-                <a:spcPts val="1000"/>
-              </a:spcAft>
-            </a:pPr>
-            <a:r>
-              <a:rPr sz="1500" b="0">
+            <a:r>
+              <a:rPr sz="1200" b="0">
                 <a:solidFill>
-                  <a:srgbClr val="C8D2E1"/>
+                  <a:srgbClr val="C6D0E0"/>
                 </a:solidFill>
-                <a:latin typeface="Times New Roman"/>
+                <a:latin typeface="Calibri"/>
               </a:rPr>
-              <a:t>Docker image size vs EC2 RAM — PyTorch + scientific stack lengthened build cycles and demanded tier sizing discipline.</a:t>
-            </a:r>
-          </a:p>
-          <a:p>
-            <a:pPr>
-              <a:spcAft>
-                <a:spcPts val="1000"/>
-              </a:spcAft>
-            </a:pPr>
-            <a:r>
-              <a:rPr sz="1500" b="0">
-                <a:solidFill>
-                  <a:srgbClr val="C8D2E1"/>
-                </a:solidFill>
-                <a:latin typeface="Times New Roman"/>
-              </a:rPr>
-              <a:t>Binding Compose services to loopback while exposing nginx-only ingress complicated smoke-testing.</a:t>
-            </a:r>
-          </a:p>
-          <a:p>
-            <a:pPr>
-              <a:spcAft>
-                <a:spcPts val="1000"/>
-              </a:spcAft>
-            </a:pPr>
-            <a:r>
-              <a:rPr sz="1500" b="0">
-                <a:solidFill>
-                  <a:srgbClr val="C8D2E1"/>
-                </a:solidFill>
-                <a:latin typeface="Times New Roman"/>
-              </a:rPr>
-              <a:t>NEXT_PUBLIC_API_URL correctness — Axios base URL must match TLS-terminated hostname behind proxy.</a:t>
-            </a:r>
-          </a:p>
-          <a:p>
-            <a:pPr>
-              <a:spcAft>
-                <a:spcPts val="1000"/>
-              </a:spcAft>
-            </a:pPr>
-            <a:r>
-              <a:rPr sz="1500" b="0">
-                <a:solidFill>
-                  <a:srgbClr val="C8D2E1"/>
-                </a:solidFill>
-                <a:latin typeface="Times New Roman"/>
-              </a:rPr>
-              <a:t>Prometheus cardinality control — middleware templates route paths to avoid exploding labels with patient IDs.</a:t>
-            </a:r>
-          </a:p>
-          <a:p>
-            <a:pPr>
-              <a:spcAft>
-                <a:spcPts val="1000"/>
-              </a:spcAft>
-            </a:pPr>
-            <a:r>
-              <a:rPr sz="1500" b="0">
-                <a:solidFill>
-                  <a:srgbClr val="C8D2E1"/>
-                </a:solidFill>
-                <a:latin typeface="Times New Roman"/>
-              </a:rPr>
-              <a:t>Robust preprocessing — graceful degradation when SciPy / NeuroKit2 / PyWavelets absent for lightweight CI.</a:t>
-            </a:r>
-          </a:p>
-          <a:p>
-            <a:pPr>
-              <a:spcAft>
-                <a:spcPts val="1000"/>
-              </a:spcAft>
-            </a:pPr>
-            <a:r>
-              <a:rPr sz="1500" b="0">
-                <a:solidFill>
-                  <a:srgbClr val="C8D2E1"/>
-                </a:solidFill>
-                <a:latin typeface="Times New Roman"/>
-              </a:rPr>
-              <a:t>XAI dependency drift — Captum/SHAP optional imports require heuristic fallbacks without breaking API contracts.</a:t>
-            </a:r>
-          </a:p>
-        </p:txBody>
-      </p:sp>
+              <a:t>Practical constraints encountered integrating ML + observability + full-stack deployment.</a:t>
+            </a:r>
+          </a:p>
+        </p:txBody>
+      </p:sp>
+      <p:pic>
+        <p:nvPicPr>
+          <p:cNvPr id="5" name="Picture 4" descr="tmp41x1h2fn.png"/>
+          <p:cNvPicPr>
+            <a:picLocks noChangeAspect="1"/>
+          </p:cNvPicPr>
+          <p:nvPr/>
+        </p:nvPicPr>
+        <p:blipFill>
+          <a:blip r:embed="rId2"/>
+          <a:stretch>
+            <a:fillRect/>
+          </a:stretch>
+        </p:blipFill>
+        <p:spPr>
+          <a:xfrm>
+            <a:off x="411480" y="1389888"/>
+            <a:ext cx="11384280" cy="5042945"/>
+          </a:xfrm>
+          <a:prstGeom prst="rect">
+            <a:avLst/>
+          </a:prstGeom>
+        </p:spPr>
+      </p:pic>
     </p:spTree>
   </p:cSld>
   <p:clrMapOvr>
@@ -4127,14 +4072,57 @@
       <p:grpSpPr/>
       <p:sp>
         <p:nvSpPr>
-          <p:cNvPr id="2" name="TextBox 1"/>
+          <p:cNvPr id="2" name="Rectangle 1"/>
+          <p:cNvSpPr/>
+          <p:nvPr/>
+        </p:nvSpPr>
+        <p:spPr>
+          <a:xfrm>
+            <a:off x="0" y="347472"/>
+            <a:ext cx="12191999" cy="54864"/>
+          </a:xfrm>
+          <a:prstGeom prst="rect">
+            <a:avLst/>
+          </a:prstGeom>
+          <a:solidFill>
+            <a:srgbClr val="2A9D8F"/>
+          </a:solidFill>
+          <a:ln>
+            <a:noFill/>
+          </a:ln>
+        </p:spPr>
+        <p:style>
+          <a:lnRef idx="1">
+            <a:schemeClr val="accent1"/>
+          </a:lnRef>
+          <a:fillRef idx="3">
+            <a:schemeClr val="accent1"/>
+          </a:fillRef>
+          <a:effectRef idx="2">
+            <a:schemeClr val="accent1"/>
+          </a:effectRef>
+          <a:fontRef idx="minor">
+            <a:schemeClr val="lt1"/>
+          </a:fontRef>
+        </p:style>
+        <p:txBody>
+          <a:bodyPr rtlCol="0" anchor="ctr"/>
+          <a:lstStyle/>
+          <a:p>
+            <a:pPr algn="ctr"/>
+          </a:p>
+        </p:txBody>
+      </p:sp>
+      <p:sp>
+        <p:nvSpPr>
+          <p:cNvPr id="3" name="TextBox 2"/>
           <p:cNvSpPr txBox="1"/>
           <p:nvPr/>
         </p:nvSpPr>
         <p:spPr>
           <a:xfrm>
-            <a:off x="502920" y="411480"/>
-            <a:ext cx="10972800" cy="777240"/>
+            <a:off x="502920" y="475488"/>
+            <a:ext cx="11155680" cy="822960"/>
           </a:xfrm>
           <a:prstGeom prst="rect">
             <a:avLst/>
@@ -4148,7 +4136,7 @@
           <a:lstStyle/>
           <a:p>
             <a:r>
-              <a:rPr sz="2600" b="1">
+              <a:rPr sz="2800" b="1">
                 <a:solidFill>
                   <a:srgbClr val="FFFFFF"/>
                 </a:solidFill>
@@ -4159,125 +4147,30 @@
           </a:p>
         </p:txBody>
       </p:sp>
-      <p:sp>
-        <p:nvSpPr>
-          <p:cNvPr id="3" name="TextBox 2"/>
-          <p:cNvSpPr txBox="1"/>
+      <p:pic>
+        <p:nvPicPr>
+          <p:cNvPr id="4" name="Picture 3" descr="tmppf77h2gx.png"/>
+          <p:cNvPicPr>
+            <a:picLocks noChangeAspect="1"/>
+          </p:cNvPicPr>
           <p:nvPr/>
-        </p:nvSpPr>
-        <p:spPr>
-          <a:xfrm>
-            <a:off x="685800" y="1234440"/>
-            <a:ext cx="10789920" cy="5394960"/>
-          </a:xfrm>
-          <a:prstGeom prst="rect">
-            <a:avLst/>
-          </a:prstGeom>
-          <a:noFill/>
-        </p:spPr>
-        <p:txBody>
-          <a:bodyPr wrap="square">
-            <a:spAutoFit/>
-          </a:bodyPr>
-          <a:lstStyle/>
-          <a:p>
-            <a:pPr>
-              <a:spcAft>
-                <a:spcPts val="1000"/>
-              </a:spcAft>
-            </a:pPr>
-            <a:r>
-              <a:rPr sz="1500" b="0">
-                <a:solidFill>
-                  <a:srgbClr val="C8D2E1"/>
-                </a:solidFill>
-                <a:latin typeface="Times New Roman"/>
-              </a:rPr>
-              <a:t>CNN–BiLSTM fusion captures spectro-temporal AMI cues while emitting dual clinical endpoints in one forward pass.</a:t>
-            </a:r>
-          </a:p>
-          <a:p>
-            <a:pPr>
-              <a:spcAft>
-                <a:spcPts val="1000"/>
-              </a:spcAft>
-            </a:pPr>
-            <a:r>
-              <a:rPr sz="1500" b="0">
-                <a:solidFill>
-                  <a:srgbClr val="C8D2E1"/>
-                </a:solidFill>
-                <a:latin typeface="Times New Roman"/>
-              </a:rPr>
-              <a:t>Explainability hooks (Grad-CAM + SHAP-proxy features) align model outputs with inspectable physiology.</a:t>
-            </a:r>
-          </a:p>
-          <a:p>
-            <a:pPr>
-              <a:spcAft>
-                <a:spcPts val="1000"/>
-              </a:spcAft>
-            </a:pPr>
-            <a:r>
-              <a:rPr sz="1500" b="0">
-                <a:solidFill>
-                  <a:srgbClr val="C8D2E1"/>
-                </a:solidFill>
-                <a:latin typeface="Times New Roman"/>
-              </a:rPr>
-              <a:t>Cloud-native packaging (Compose + nginx + EC2) demonstrates deployable CDS engineering beyond notebook prototypes.</a:t>
-            </a:r>
-          </a:p>
-          <a:p>
-            <a:pPr>
-              <a:spcAft>
-                <a:spcPts val="1000"/>
-              </a:spcAft>
-            </a:pPr>
-            <a:r>
-              <a:rPr sz="1500" b="0">
-                <a:solidFill>
-                  <a:srgbClr val="C8D2E1"/>
-                </a:solidFill>
-                <a:latin typeface="Times New Roman"/>
-              </a:rPr>
-              <a:t>Prometheus/Grafana closes the loop on latency drift and alert storms.</a:t>
-            </a:r>
-          </a:p>
-          <a:p>
-            <a:pPr>
-              <a:spcAft>
-                <a:spcPts val="1000"/>
-              </a:spcAft>
-            </a:pPr>
-            <a:r>
-              <a:rPr sz="1500" b="0">
-                <a:solidFill>
-                  <a:srgbClr val="C8D2E1"/>
-                </a:solidFill>
-                <a:latin typeface="Times New Roman"/>
-              </a:rPr>
-              <a:t>Future scope: wearable streams · mobile clients · multi-site rollout · PostgreSQL migration · transformer encoders.</a:t>
-            </a:r>
-          </a:p>
-          <a:p>
-            <a:pPr>
-              <a:spcAft>
-                <a:spcPts val="1000"/>
-              </a:spcAft>
-            </a:pPr>
-            <a:r>
-              <a:rPr sz="1500" b="0">
-                <a:solidFill>
-                  <a:srgbClr val="C8D2E1"/>
-                </a:solidFill>
-                <a:latin typeface="Times New Roman"/>
-              </a:rPr>
-              <a:t>Thank you.</a:t>
-            </a:r>
-          </a:p>
-        </p:txBody>
-      </p:sp>
+        </p:nvPicPr>
+        <p:blipFill>
+          <a:blip r:embed="rId2"/>
+          <a:stretch>
+            <a:fillRect/>
+          </a:stretch>
+        </p:blipFill>
+        <p:spPr>
+          <a:xfrm>
+            <a:off x="411480" y="1261872"/>
+            <a:ext cx="11384280" cy="5348697"/>
+          </a:xfrm>
+          <a:prstGeom prst="rect">
+            <a:avLst/>
+          </a:prstGeom>
+        </p:spPr>
+      </p:pic>
     </p:spTree>
   </p:cSld>
   <p:clrMapOvr>
@@ -4306,14 +4199,57 @@
       <p:grpSpPr/>
       <p:sp>
         <p:nvSpPr>
-          <p:cNvPr id="2" name="TextBox 1"/>
+          <p:cNvPr id="2" name="Rectangle 1"/>
+          <p:cNvSpPr/>
+          <p:nvPr/>
+        </p:nvSpPr>
+        <p:spPr>
+          <a:xfrm>
+            <a:off x="0" y="347472"/>
+            <a:ext cx="12191999" cy="54864"/>
+          </a:xfrm>
+          <a:prstGeom prst="rect">
+            <a:avLst/>
+          </a:prstGeom>
+          <a:solidFill>
+            <a:srgbClr val="2A9D8F"/>
+          </a:solidFill>
+          <a:ln>
+            <a:noFill/>
+          </a:ln>
+        </p:spPr>
+        <p:style>
+          <a:lnRef idx="1">
+            <a:schemeClr val="accent1"/>
+          </a:lnRef>
+          <a:fillRef idx="3">
+            <a:schemeClr val="accent1"/>
+          </a:fillRef>
+          <a:effectRef idx="2">
+            <a:schemeClr val="accent1"/>
+          </a:effectRef>
+          <a:fontRef idx="minor">
+            <a:schemeClr val="lt1"/>
+          </a:fontRef>
+        </p:style>
+        <p:txBody>
+          <a:bodyPr rtlCol="0" anchor="ctr"/>
+          <a:lstStyle/>
+          <a:p>
+            <a:pPr algn="ctr"/>
+          </a:p>
+        </p:txBody>
+      </p:sp>
+      <p:sp>
+        <p:nvSpPr>
+          <p:cNvPr id="3" name="TextBox 2"/>
           <p:cNvSpPr txBox="1"/>
           <p:nvPr/>
         </p:nvSpPr>
         <p:spPr>
           <a:xfrm>
-            <a:off x="502920" y="411480"/>
-            <a:ext cx="10972800" cy="777240"/>
+            <a:off x="502920" y="475488"/>
+            <a:ext cx="11155680" cy="822960"/>
           </a:xfrm>
           <a:prstGeom prst="rect">
             <a:avLst/>
@@ -4327,27 +4263,27 @@
           <a:lstStyle/>
           <a:p>
             <a:r>
-              <a:rPr sz="2600" b="1">
+              <a:rPr sz="2800" b="1">
                 <a:solidFill>
                   <a:srgbClr val="FFFFFF"/>
                 </a:solidFill>
                 <a:latin typeface="Times New Roman"/>
               </a:rPr>
-              <a:t>Problem statement</a:t>
-            </a:r>
-          </a:p>
-        </p:txBody>
-      </p:sp>
-      <p:sp>
-        <p:nvSpPr>
-          <p:cNvPr id="3" name="TextBox 2"/>
+              <a:t>Problem statement — clinical workflow friction</a:t>
+            </a:r>
+          </a:p>
+        </p:txBody>
+      </p:sp>
+      <p:sp>
+        <p:nvSpPr>
+          <p:cNvPr id="4" name="TextBox 3"/>
           <p:cNvSpPr txBox="1"/>
           <p:nvPr/>
         </p:nvSpPr>
         <p:spPr>
           <a:xfrm>
-            <a:off x="685800" y="1234440"/>
-            <a:ext cx="10789920" cy="5394960"/>
+            <a:off x="548640" y="987552"/>
+            <a:ext cx="10972800" cy="411480"/>
           </a:xfrm>
           <a:prstGeom prst="rect">
             <a:avLst/>
@@ -4355,92 +4291,47 @@
           <a:noFill/>
         </p:spPr>
         <p:txBody>
-          <a:bodyPr wrap="square">
+          <a:bodyPr wrap="none">
             <a:spAutoFit/>
           </a:bodyPr>
           <a:lstStyle/>
           <a:p>
-            <a:pPr>
-              <a:spcAft>
-                <a:spcPts val="1000"/>
-              </a:spcAft>
-            </a:pPr>
-            <a:r>
-              <a:rPr sz="1500" b="0">
+            <a:r>
+              <a:rPr sz="1200" b="0">
                 <a:solidFill>
-                  <a:srgbClr val="C8D2E1"/>
+                  <a:srgbClr val="C6D0E0"/>
                 </a:solidFill>
-                <a:latin typeface="Times New Roman"/>
+                <a:latin typeface="Calibri"/>
               </a:rPr>
-              <a:t>AMI care quality depends on rapid recognition; delayed diagnosis narrows revascularization benefit.</a:t>
-            </a:r>
-          </a:p>
-          <a:p>
-            <a:pPr>
-              <a:spcAft>
-                <a:spcPts val="1000"/>
-              </a:spcAft>
-            </a:pPr>
-            <a:r>
-              <a:rPr sz="1500" b="0">
-                <a:solidFill>
-                  <a:srgbClr val="C8D2E1"/>
-                </a:solidFill>
-                <a:latin typeface="Times New Roman"/>
-              </a:rPr>
-              <a:t>Standard workflows rely heavily on manual ECG interpretation — expertise-dependent and variable under load.</a:t>
-            </a:r>
-          </a:p>
-          <a:p>
-            <a:pPr>
-              <a:spcAft>
-                <a:spcPts val="1000"/>
-              </a:spcAft>
-            </a:pPr>
-            <a:r>
-              <a:rPr sz="1500" b="0">
-                <a:solidFill>
-                  <a:srgbClr val="C8D2E1"/>
-                </a:solidFill>
-                <a:latin typeface="Times New Roman"/>
-              </a:rPr>
-              <a:t>Interpretation fatigue and communication gaps increase missed STEMI-equivalent patterns.</a:t>
-            </a:r>
-          </a:p>
-          <a:p>
-            <a:pPr>
-              <a:spcAft>
-                <a:spcPts val="1000"/>
-              </a:spcAft>
-            </a:pPr>
-            <a:r>
-              <a:rPr sz="1500" b="0">
-                <a:solidFill>
-                  <a:srgbClr val="C8D2E1"/>
-                </a:solidFill>
-                <a:latin typeface="Times New Roman"/>
-              </a:rPr>
-              <a:t>Hospital-grade CDS rarely bundles deep-learning inference with observability at internship-ready deployment depth.</a:t>
-            </a:r>
-          </a:p>
-          <a:p>
-            <a:pPr>
-              <a:spcAft>
-                <a:spcPts val="1000"/>
-              </a:spcAft>
-            </a:pPr>
-            <a:r>
-              <a:rPr sz="1500" b="0">
-                <a:solidFill>
-                  <a:srgbClr val="C8D2E1"/>
-                </a:solidFill>
-                <a:latin typeface="Times New Roman"/>
-              </a:rPr>
-              <a:t>Clinical stakeholders require transparency (why this risk?) alongside numeric scores.</a:t>
-            </a:r>
-          </a:p>
-        </p:txBody>
-      </p:sp>
+              <a:t>Real-world delays and gaps motivating instrumented CDS + monitoring.</a:t>
+            </a:r>
+          </a:p>
+        </p:txBody>
+      </p:sp>
+      <p:pic>
+        <p:nvPicPr>
+          <p:cNvPr id="5" name="Picture 4" descr="tmpa2i1utt2.png"/>
+          <p:cNvPicPr>
+            <a:picLocks noChangeAspect="1"/>
+          </p:cNvPicPr>
+          <p:nvPr/>
+        </p:nvPicPr>
+        <p:blipFill>
+          <a:blip r:embed="rId2"/>
+          <a:stretch>
+            <a:fillRect/>
+          </a:stretch>
+        </p:blipFill>
+        <p:spPr>
+          <a:xfrm>
+            <a:off x="411480" y="1389888"/>
+            <a:ext cx="11384280" cy="5091785"/>
+          </a:xfrm>
+          <a:prstGeom prst="rect">
+            <a:avLst/>
+          </a:prstGeom>
+        </p:spPr>
+      </p:pic>
     </p:spTree>
   </p:cSld>
   <p:clrMapOvr>
@@ -4469,14 +4360,57 @@
       <p:grpSpPr/>
       <p:sp>
         <p:nvSpPr>
-          <p:cNvPr id="2" name="TextBox 1"/>
+          <p:cNvPr id="2" name="Rectangle 1"/>
+          <p:cNvSpPr/>
+          <p:nvPr/>
+        </p:nvSpPr>
+        <p:spPr>
+          <a:xfrm>
+            <a:off x="0" y="347472"/>
+            <a:ext cx="12191999" cy="54864"/>
+          </a:xfrm>
+          <a:prstGeom prst="rect">
+            <a:avLst/>
+          </a:prstGeom>
+          <a:solidFill>
+            <a:srgbClr val="2A9D8F"/>
+          </a:solidFill>
+          <a:ln>
+            <a:noFill/>
+          </a:ln>
+        </p:spPr>
+        <p:style>
+          <a:lnRef idx="1">
+            <a:schemeClr val="accent1"/>
+          </a:lnRef>
+          <a:fillRef idx="3">
+            <a:schemeClr val="accent1"/>
+          </a:fillRef>
+          <a:effectRef idx="2">
+            <a:schemeClr val="accent1"/>
+          </a:effectRef>
+          <a:fontRef idx="minor">
+            <a:schemeClr val="lt1"/>
+          </a:fontRef>
+        </p:style>
+        <p:txBody>
+          <a:bodyPr rtlCol="0" anchor="ctr"/>
+          <a:lstStyle/>
+          <a:p>
+            <a:pPr algn="ctr"/>
+          </a:p>
+        </p:txBody>
+      </p:sp>
+      <p:sp>
+        <p:nvSpPr>
+          <p:cNvPr id="3" name="TextBox 2"/>
           <p:cNvSpPr txBox="1"/>
           <p:nvPr/>
         </p:nvSpPr>
         <p:spPr>
           <a:xfrm>
-            <a:off x="502920" y="411480"/>
-            <a:ext cx="10972800" cy="777240"/>
+            <a:off x="502920" y="475488"/>
+            <a:ext cx="11155680" cy="822960"/>
           </a:xfrm>
           <a:prstGeom prst="rect">
             <a:avLst/>
@@ -4490,7 +4424,7 @@
           <a:lstStyle/>
           <a:p>
             <a:r>
-              <a:rPr sz="2600" b="1">
+              <a:rPr sz="2800" b="1">
                 <a:solidFill>
                   <a:srgbClr val="FFFFFF"/>
                 </a:solidFill>
@@ -4503,14 +4437,14 @@
       </p:sp>
       <p:sp>
         <p:nvSpPr>
-          <p:cNvPr id="3" name="TextBox 2"/>
+          <p:cNvPr id="4" name="TextBox 3"/>
           <p:cNvSpPr txBox="1"/>
           <p:nvPr/>
         </p:nvSpPr>
         <p:spPr>
           <a:xfrm>
-            <a:off x="685800" y="1234440"/>
-            <a:ext cx="10789920" cy="5394960"/>
+            <a:off x="548640" y="987552"/>
+            <a:ext cx="10972800" cy="411480"/>
           </a:xfrm>
           <a:prstGeom prst="rect">
             <a:avLst/>
@@ -4518,108 +4452,47 @@
           <a:noFill/>
         </p:spPr>
         <p:txBody>
-          <a:bodyPr wrap="square">
+          <a:bodyPr wrap="none">
             <a:spAutoFit/>
           </a:bodyPr>
           <a:lstStyle/>
           <a:p>
-            <a:pPr>
-              <a:spcAft>
-                <a:spcPts val="1000"/>
-              </a:spcAft>
-            </a:pPr>
-            <a:r>
-              <a:rPr sz="1500" b="0">
+            <a:r>
+              <a:rPr sz="1200" b="0">
                 <a:solidFill>
-                  <a:srgbClr val="C8D2E1"/>
+                  <a:srgbClr val="C6D0E0"/>
                 </a:solidFill>
-                <a:latin typeface="Times New Roman"/>
+                <a:latin typeface="Calibri"/>
               </a:rPr>
-              <a:t>Detect AMI likelihood from 12-lead ECG signals via multi-branch CNN–BiLSTM (PyTorch).</a:t>
-            </a:r>
-          </a:p>
-          <a:p>
-            <a:pPr>
-              <a:spcAft>
-                <a:spcPts val="1000"/>
-              </a:spcAft>
-            </a:pPr>
-            <a:r>
-              <a:rPr sz="1500" b="0">
-                <a:solidFill>
-                  <a:srgbClr val="C8D2E1"/>
-                </a:solidFill>
-                <a:latin typeface="Times New Roman"/>
-              </a:rPr>
-              <a:t>Co-predict PCI/CABG (revascularization) need using the shared fused representation.</a:t>
-            </a:r>
-          </a:p>
-          <a:p>
-            <a:pPr>
-              <a:spcAft>
-                <a:spcPts val="1000"/>
-              </a:spcAft>
-            </a:pPr>
-            <a:r>
-              <a:rPr sz="1500" b="0">
-                <a:solidFill>
-                  <a:srgbClr val="C8D2E1"/>
-                </a:solidFill>
-                <a:latin typeface="Times New Roman"/>
-              </a:rPr>
-              <a:t>Expose explainability: Grad-CAM-style lead saliency + SHAP-like morphological/spectral attributions.</a:t>
-            </a:r>
-          </a:p>
-          <a:p>
-            <a:pPr>
-              <a:spcAft>
-                <a:spcPts val="1000"/>
-              </a:spcAft>
-            </a:pPr>
-            <a:r>
-              <a:rPr sz="1500" b="0">
-                <a:solidFill>
-                  <a:srgbClr val="C8D2E1"/>
-                </a:solidFill>
-                <a:latin typeface="Times New Roman"/>
-              </a:rPr>
-              <a:t>Deliver clinician-facing workflows: upload/analyse, history, explain route, alerts UI.</a:t>
-            </a:r>
-          </a:p>
-          <a:p>
-            <a:pPr>
-              <a:spcAft>
-                <a:spcPts val="1000"/>
-              </a:spcAft>
-            </a:pPr>
-            <a:r>
-              <a:rPr sz="1500" b="0">
-                <a:solidFill>
-                  <a:srgbClr val="C8D2E1"/>
-                </a:solidFill>
-                <a:latin typeface="Times New Roman"/>
-              </a:rPr>
-              <a:t>Deploy on AWS EC2 using Docker Compose + nginx with JWT auth and OTP registration.</a:t>
-            </a:r>
-          </a:p>
-          <a:p>
-            <a:pPr>
-              <a:spcAft>
-                <a:spcPts val="1000"/>
-              </a:spcAft>
-            </a:pPr>
-            <a:r>
-              <a:rPr sz="1500" b="0">
-                <a:solidFill>
-                  <a:srgbClr val="C8D2E1"/>
-                </a:solidFill>
-                <a:latin typeface="Times New Roman"/>
-              </a:rPr>
-              <a:t>Instrument Prometheus (/metrics) and Grafana dashboards for latency, traffic, and AMI tier counters.</a:t>
-            </a:r>
-          </a:p>
-        </p:txBody>
-      </p:sp>
+              <a:t>Six capability pillars implemented across FastAPI, Next.js, PyTorch, and the compose stack.</a:t>
+            </a:r>
+          </a:p>
+        </p:txBody>
+      </p:sp>
+      <p:pic>
+        <p:nvPicPr>
+          <p:cNvPr id="5" name="Picture 4" descr="tmpwy21fkby.png"/>
+          <p:cNvPicPr>
+            <a:picLocks noChangeAspect="1"/>
+          </p:cNvPicPr>
+          <p:nvPr/>
+        </p:nvPicPr>
+        <p:blipFill>
+          <a:blip r:embed="rId2"/>
+          <a:stretch>
+            <a:fillRect/>
+          </a:stretch>
+        </p:blipFill>
+        <p:spPr>
+          <a:xfrm>
+            <a:off x="411480" y="1389888"/>
+            <a:ext cx="11384280" cy="5042945"/>
+          </a:xfrm>
+          <a:prstGeom prst="rect">
+            <a:avLst/>
+          </a:prstGeom>
+        </p:spPr>
+      </p:pic>
     </p:spTree>
   </p:cSld>
   <p:clrMapOvr>
@@ -4648,14 +4521,57 @@
       <p:grpSpPr/>
       <p:sp>
         <p:nvSpPr>
-          <p:cNvPr id="2" name="TextBox 1"/>
+          <p:cNvPr id="2" name="Rectangle 1"/>
+          <p:cNvSpPr/>
+          <p:nvPr/>
+        </p:nvSpPr>
+        <p:spPr>
+          <a:xfrm>
+            <a:off x="0" y="347472"/>
+            <a:ext cx="12191999" cy="54864"/>
+          </a:xfrm>
+          <a:prstGeom prst="rect">
+            <a:avLst/>
+          </a:prstGeom>
+          <a:solidFill>
+            <a:srgbClr val="2A9D8F"/>
+          </a:solidFill>
+          <a:ln>
+            <a:noFill/>
+          </a:ln>
+        </p:spPr>
+        <p:style>
+          <a:lnRef idx="1">
+            <a:schemeClr val="accent1"/>
+          </a:lnRef>
+          <a:fillRef idx="3">
+            <a:schemeClr val="accent1"/>
+          </a:fillRef>
+          <a:effectRef idx="2">
+            <a:schemeClr val="accent1"/>
+          </a:effectRef>
+          <a:fontRef idx="minor">
+            <a:schemeClr val="lt1"/>
+          </a:fontRef>
+        </p:style>
+        <p:txBody>
+          <a:bodyPr rtlCol="0" anchor="ctr"/>
+          <a:lstStyle/>
+          <a:p>
+            <a:pPr algn="ctr"/>
+          </a:p>
+        </p:txBody>
+      </p:sp>
+      <p:sp>
+        <p:nvSpPr>
+          <p:cNvPr id="3" name="TextBox 2"/>
           <p:cNvSpPr txBox="1"/>
           <p:nvPr/>
         </p:nvSpPr>
         <p:spPr>
           <a:xfrm>
-            <a:off x="502920" y="411480"/>
-            <a:ext cx="10972800" cy="777240"/>
+            <a:off x="502920" y="475488"/>
+            <a:ext cx="11155680" cy="822960"/>
           </a:xfrm>
           <a:prstGeom prst="rect">
             <a:avLst/>
@@ -4669,452 +4585,75 @@
           <a:lstStyle/>
           <a:p>
             <a:r>
-              <a:rPr sz="2600" b="1">
+              <a:rPr sz="2800" b="1">
                 <a:solidFill>
                   <a:srgbClr val="FFFFFF"/>
                 </a:solidFill>
                 <a:latin typeface="Times New Roman"/>
               </a:rPr>
-              <a:t>Existing vs proposed system</a:t>
-            </a:r>
-          </a:p>
-        </p:txBody>
-      </p:sp>
-      <p:graphicFrame>
-        <p:nvGraphicFramePr>
-          <p:cNvPr id="3" name="Table 2"/>
-          <p:cNvGraphicFramePr>
-            <a:graphicFrameLocks noGrp="1"/>
-          </p:cNvGraphicFramePr>
+              <a:t>Traditional vs CardioSense workflow</a:t>
+            </a:r>
+          </a:p>
+        </p:txBody>
+      </p:sp>
+      <p:sp>
+        <p:nvSpPr>
+          <p:cNvPr id="4" name="TextBox 3"/>
+          <p:cNvSpPr txBox="1"/>
           <p:nvPr/>
-        </p:nvGraphicFramePr>
-        <p:xfrm>
-          <a:off x="822960" y="1234440"/>
-          <a:ext cx="10515600" cy="2304288"/>
-        </p:xfrm>
-        <a:graphic>
-          <a:graphicData uri="http://schemas.openxmlformats.org/drawingml/2006/table">
-            <a:tbl>
-              <a:tblPr firstRow="1" bandRow="1">
-                <a:tableStyleId>{5C22544A-7EE6-4342-B048-85BDC9FD1C3A}</a:tableStyleId>
-              </a:tblPr>
-              <a:tblGrid>
-                <a:gridCol w="3505200"/>
-                <a:gridCol w="3505200"/>
-                <a:gridCol w="3505200"/>
-              </a:tblGrid>
-              <a:tr h="384048">
-                <a:tc>
-                  <a:txBody>
-                    <a:bodyPr/>
-                    <a:lstStyle/>
-                    <a:p>
-                      <a:r>
-                        <a:rPr sz="1300" b="1">
-                          <a:solidFill>
-                            <a:srgbClr val="FFFFFF"/>
-                          </a:solidFill>
-                          <a:latin typeface="Times New Roman"/>
-                        </a:rPr>
-                        <a:t>Aspect</a:t>
-                      </a:r>
-                    </a:p>
-                  </a:txBody>
-                  <a:tcPr>
-                    <a:solidFill>
-                      <a:srgbClr val="1B263B"/>
-                    </a:solidFill>
-                  </a:tcPr>
-                </a:tc>
-                <a:tc>
-                  <a:txBody>
-                    <a:bodyPr/>
-                    <a:lstStyle/>
-                    <a:p>
-                      <a:r>
-                        <a:rPr sz="1300" b="1">
-                          <a:solidFill>
-                            <a:srgbClr val="FFFFFF"/>
-                          </a:solidFill>
-                          <a:latin typeface="Times New Roman"/>
-                        </a:rPr>
-                        <a:t>Existing / conventional</a:t>
-                      </a:r>
-                    </a:p>
-                  </a:txBody>
-                  <a:tcPr>
-                    <a:solidFill>
-                      <a:srgbClr val="1B263B"/>
-                    </a:solidFill>
-                  </a:tcPr>
-                </a:tc>
-                <a:tc>
-                  <a:txBody>
-                    <a:bodyPr/>
-                    <a:lstStyle/>
-                    <a:p>
-                      <a:r>
-                        <a:rPr sz="1300" b="1">
-                          <a:solidFill>
-                            <a:srgbClr val="FFFFFF"/>
-                          </a:solidFill>
-                          <a:latin typeface="Times New Roman"/>
-                        </a:rPr>
-                        <a:t>Proposed · CardioSense implementation</a:t>
-                      </a:r>
-                    </a:p>
-                  </a:txBody>
-                  <a:tcPr>
-                    <a:solidFill>
-                      <a:srgbClr val="1B263B"/>
-                    </a:solidFill>
-                  </a:tcPr>
-                </a:tc>
-              </a:tr>
-              <a:tr h="384048">
-                <a:tc>
-                  <a:txBody>
-                    <a:bodyPr/>
-                    <a:lstStyle/>
-                    <a:p>
-                      <a:r>
-                        <a:rPr sz="1300" b="0">
-                          <a:solidFill>
-                            <a:srgbClr val="C8D2E1"/>
-                          </a:solidFill>
-                          <a:latin typeface="Times New Roman"/>
-                        </a:rPr>
-                        <a:t>Interpretation</a:t>
-                      </a:r>
-                    </a:p>
-                  </a:txBody>
-                  <a:tcPr>
-                    <a:solidFill>
-                      <a:srgbClr val="0D1B2A"/>
-                    </a:solidFill>
-                  </a:tcPr>
-                </a:tc>
-                <a:tc>
-                  <a:txBody>
-                    <a:bodyPr/>
-                    <a:lstStyle/>
-                    <a:p>
-                      <a:r>
-                        <a:rPr sz="1300" b="0">
-                          <a:solidFill>
-                            <a:srgbClr val="C8D2E1"/>
-                          </a:solidFill>
-                          <a:latin typeface="Times New Roman"/>
-                        </a:rPr>
-                        <a:t>Manual reading; siloed viewers</a:t>
-                      </a:r>
-                    </a:p>
-                  </a:txBody>
-                  <a:tcPr>
-                    <a:solidFill>
-                      <a:srgbClr val="0D1B2A"/>
-                    </a:solidFill>
-                  </a:tcPr>
-                </a:tc>
-                <a:tc>
-                  <a:txBody>
-                    <a:bodyPr/>
-                    <a:lstStyle/>
-                    <a:p>
-                      <a:r>
-                        <a:rPr sz="1300" b="0">
-                          <a:solidFill>
-                            <a:srgbClr val="C8D2E1"/>
-                          </a:solidFill>
-                          <a:latin typeface="Times New Roman"/>
-                        </a:rPr>
-                        <a:t>AI-assisted scoring + retained human oversight</a:t>
-                      </a:r>
-                    </a:p>
-                  </a:txBody>
-                  <a:tcPr>
-                    <a:solidFill>
-                      <a:srgbClr val="0D1B2A"/>
-                    </a:solidFill>
-                  </a:tcPr>
-                </a:tc>
-              </a:tr>
-              <a:tr h="384048">
-                <a:tc>
-                  <a:txBody>
-                    <a:bodyPr/>
-                    <a:lstStyle/>
-                    <a:p>
-                      <a:r>
-                        <a:rPr sz="1300" b="0">
-                          <a:solidFill>
-                            <a:srgbClr val="C8D2E1"/>
-                          </a:solidFill>
-                          <a:latin typeface="Times New Roman"/>
-                        </a:rPr>
-                        <a:t>Throughput</a:t>
-                      </a:r>
-                    </a:p>
-                  </a:txBody>
-                  <a:tcPr>
-                    <a:solidFill>
-                      <a:srgbClr val="0D1B2A"/>
-                    </a:solidFill>
-                  </a:tcPr>
-                </a:tc>
-                <a:tc>
-                  <a:txBody>
-                    <a:bodyPr/>
-                    <a:lstStyle/>
-                    <a:p>
-                      <a:r>
-                        <a:rPr sz="1300" b="0">
-                          <a:solidFill>
-                            <a:srgbClr val="C8D2E1"/>
-                          </a:solidFill>
-                          <a:latin typeface="Times New Roman"/>
-                        </a:rPr>
-                        <a:t>Queue-limited during surge</a:t>
-                      </a:r>
-                    </a:p>
-                  </a:txBody>
-                  <a:tcPr>
-                    <a:solidFill>
-                      <a:srgbClr val="0D1B2A"/>
-                    </a:solidFill>
-                  </a:tcPr>
-                </a:tc>
-                <a:tc>
-                  <a:txBody>
-                    <a:bodyPr/>
-                    <a:lstStyle/>
-                    <a:p>
-                      <a:r>
-                        <a:rPr sz="1300" b="0">
-                          <a:solidFill>
-                            <a:srgbClr val="C8D2E1"/>
-                          </a:solidFill>
-                          <a:latin typeface="Times New Roman"/>
-                        </a:rPr>
-                        <a:t>FastAPI batch inference path + structured JSON responses</a:t>
-                      </a:r>
-                    </a:p>
-                  </a:txBody>
-                  <a:tcPr>
-                    <a:solidFill>
-                      <a:srgbClr val="0D1B2A"/>
-                    </a:solidFill>
-                  </a:tcPr>
-                </a:tc>
-              </a:tr>
-              <a:tr h="384048">
-                <a:tc>
-                  <a:txBody>
-                    <a:bodyPr/>
-                    <a:lstStyle/>
-                    <a:p>
-                      <a:r>
-                        <a:rPr sz="1300" b="0">
-                          <a:solidFill>
-                            <a:srgbClr val="C8D2E1"/>
-                          </a:solidFill>
-                          <a:latin typeface="Times New Roman"/>
-                        </a:rPr>
-                        <a:t>Transparency</a:t>
-                      </a:r>
-                    </a:p>
-                  </a:txBody>
-                  <a:tcPr>
-                    <a:solidFill>
-                      <a:srgbClr val="0D1B2A"/>
-                    </a:solidFill>
-                  </a:tcPr>
-                </a:tc>
-                <a:tc>
-                  <a:txBody>
-                    <a:bodyPr/>
-                    <a:lstStyle/>
-                    <a:p>
-                      <a:r>
-                        <a:rPr sz="1300" b="0">
-                          <a:solidFill>
-                            <a:srgbClr val="C8D2E1"/>
-                          </a:solidFill>
-                          <a:latin typeface="Times New Roman"/>
-                        </a:rPr>
-                        <a:t>Narrative report only</a:t>
-                      </a:r>
-                    </a:p>
-                  </a:txBody>
-                  <a:tcPr>
-                    <a:solidFill>
-                      <a:srgbClr val="0D1B2A"/>
-                    </a:solidFill>
-                  </a:tcPr>
-                </a:tc>
-                <a:tc>
-                  <a:txBody>
-                    <a:bodyPr/>
-                    <a:lstStyle/>
-                    <a:p>
-                      <a:r>
-                        <a:rPr sz="1300" b="0">
-                          <a:solidFill>
-                            <a:srgbClr val="C8D2E1"/>
-                          </a:solidFill>
-                          <a:latin typeface="Times New Roman"/>
-                        </a:rPr>
-                        <a:t>Grad-CAM lead map + SHAP-feature bars in Next.js UI</a:t>
-                      </a:r>
-                    </a:p>
-                  </a:txBody>
-                  <a:tcPr>
-                    <a:solidFill>
-                      <a:srgbClr val="0D1B2A"/>
-                    </a:solidFill>
-                  </a:tcPr>
-                </a:tc>
-              </a:tr>
-              <a:tr h="384048">
-                <a:tc>
-                  <a:txBody>
-                    <a:bodyPr/>
-                    <a:lstStyle/>
-                    <a:p>
-                      <a:r>
-                        <a:rPr sz="1300" b="0">
-                          <a:solidFill>
-                            <a:srgbClr val="C8D2E1"/>
-                          </a:solidFill>
-                          <a:latin typeface="Times New Roman"/>
-                        </a:rPr>
-                        <a:t>Monitoring</a:t>
-                      </a:r>
-                    </a:p>
-                  </a:txBody>
-                  <a:tcPr>
-                    <a:solidFill>
-                      <a:srgbClr val="0D1B2A"/>
-                    </a:solidFill>
-                  </a:tcPr>
-                </a:tc>
-                <a:tc>
-                  <a:txBody>
-                    <a:bodyPr/>
-                    <a:lstStyle/>
-                    <a:p>
-                      <a:r>
-                        <a:rPr sz="1300" b="0">
-                          <a:solidFill>
-                            <a:srgbClr val="C8D2E1"/>
-                          </a:solidFill>
-                          <a:latin typeface="Times New Roman"/>
-                        </a:rPr>
-                        <a:t>Ad hoc logs</a:t>
-                      </a:r>
-                    </a:p>
-                  </a:txBody>
-                  <a:tcPr>
-                    <a:solidFill>
-                      <a:srgbClr val="0D1B2A"/>
-                    </a:solidFill>
-                  </a:tcPr>
-                </a:tc>
-                <a:tc>
-                  <a:txBody>
-                    <a:bodyPr/>
-                    <a:lstStyle/>
-                    <a:p>
-                      <a:r>
-                        <a:rPr sz="1300" b="0">
-                          <a:solidFill>
-                            <a:srgbClr val="C8D2E1"/>
-                          </a:solidFill>
-                          <a:latin typeface="Times New Roman"/>
-                        </a:rPr>
-                        <a:t>Prometheus scrape + Grafana "CardioSense — Overview"</a:t>
-                      </a:r>
-                    </a:p>
-                  </a:txBody>
-                  <a:tcPr>
-                    <a:solidFill>
-                      <a:srgbClr val="0D1B2A"/>
-                    </a:solidFill>
-                  </a:tcPr>
-                </a:tc>
-              </a:tr>
-              <a:tr h="384048">
-                <a:tc>
-                  <a:txBody>
-                    <a:bodyPr/>
-                    <a:lstStyle/>
-                    <a:p>
-                      <a:r>
-                        <a:rPr sz="1300" b="0">
-                          <a:solidFill>
-                            <a:srgbClr val="C8D2E1"/>
-                          </a:solidFill>
-                          <a:latin typeface="Times New Roman"/>
-                        </a:rPr>
-                        <a:t>Deployment</a:t>
-                      </a:r>
-                    </a:p>
-                  </a:txBody>
-                  <a:tcPr>
-                    <a:solidFill>
-                      <a:srgbClr val="0D1B2A"/>
-                    </a:solidFill>
-                  </a:tcPr>
-                </a:tc>
-                <a:tc>
-                  <a:txBody>
-                    <a:bodyPr/>
-                    <a:lstStyle/>
-                    <a:p>
-                      <a:r>
-                        <a:rPr sz="1300" b="0">
-                          <a:solidFill>
-                            <a:srgbClr val="C8D2E1"/>
-                          </a:solidFill>
-                          <a:latin typeface="Times New Roman"/>
-                        </a:rPr>
-                        <a:t>Workstation scripts</a:t>
-                      </a:r>
-                    </a:p>
-                  </a:txBody>
-                  <a:tcPr>
-                    <a:solidFill>
-                      <a:srgbClr val="0D1B2A"/>
-                    </a:solidFill>
-                  </a:tcPr>
-                </a:tc>
-                <a:tc>
-                  <a:txBody>
-                    <a:bodyPr/>
-                    <a:lstStyle/>
-                    <a:p>
-                      <a:r>
-                        <a:rPr sz="1300" b="0">
-                          <a:solidFill>
-                            <a:srgbClr val="C8D2E1"/>
-                          </a:solidFill>
-                          <a:latin typeface="Times New Roman"/>
-                        </a:rPr>
-                        <a:t>EC2 · Docker · Compose · nginx TLS ingress</a:t>
-                      </a:r>
-                    </a:p>
-                  </a:txBody>
-                  <a:tcPr>
-                    <a:solidFill>
-                      <a:srgbClr val="0D1B2A"/>
-                    </a:solidFill>
-                  </a:tcPr>
-                </a:tc>
-              </a:tr>
-            </a:tbl>
-          </a:graphicData>
-        </a:graphic>
-      </p:graphicFrame>
+        </p:nvSpPr>
+        <p:spPr>
+          <a:xfrm>
+            <a:off x="548640" y="987552"/>
+            <a:ext cx="10972800" cy="411480"/>
+          </a:xfrm>
+          <a:prstGeom prst="rect">
+            <a:avLst/>
+          </a:prstGeom>
+          <a:noFill/>
+        </p:spPr>
+        <p:txBody>
+          <a:bodyPr wrap="none">
+            <a:spAutoFit/>
+          </a:bodyPr>
+          <a:lstStyle/>
+          <a:p>
+            <a:r>
+              <a:rPr sz="1200" b="0">
+                <a:solidFill>
+                  <a:srgbClr val="C6D0E0"/>
+                </a:solidFill>
+                <a:latin typeface="Calibri"/>
+              </a:rPr>
+              <a:t>Capability comparison grounded in repository features — not speculative performance claims.</a:t>
+            </a:r>
+          </a:p>
+        </p:txBody>
+      </p:sp>
+      <p:pic>
+        <p:nvPicPr>
+          <p:cNvPr id="5" name="Picture 4" descr="tmp3_4wvy13.png"/>
+          <p:cNvPicPr>
+            <a:picLocks noChangeAspect="1"/>
+          </p:cNvPicPr>
+          <p:nvPr/>
+        </p:nvPicPr>
+        <p:blipFill>
+          <a:blip r:embed="rId2"/>
+          <a:stretch>
+            <a:fillRect/>
+          </a:stretch>
+        </p:blipFill>
+        <p:spPr>
+          <a:xfrm>
+            <a:off x="411480" y="1389888"/>
+            <a:ext cx="11384280" cy="5309359"/>
+          </a:xfrm>
+          <a:prstGeom prst="rect">
+            <a:avLst/>
+          </a:prstGeom>
+        </p:spPr>
+      </p:pic>
     </p:spTree>
   </p:cSld>
   <p:clrMapOvr>
@@ -5143,130 +4682,23 @@
       <p:grpSpPr/>
       <p:sp>
         <p:nvSpPr>
-          <p:cNvPr id="2" name="TextBox 1"/>
-          <p:cNvSpPr txBox="1"/>
-          <p:nvPr/>
-        </p:nvSpPr>
-        <p:spPr>
-          <a:xfrm>
-            <a:off x="502920" y="320040"/>
-            <a:ext cx="10972800" cy="685800"/>
-          </a:xfrm>
-          <a:prstGeom prst="rect">
-            <a:avLst/>
-          </a:prstGeom>
-          <a:noFill/>
-        </p:spPr>
-        <p:txBody>
-          <a:bodyPr wrap="none">
-            <a:spAutoFit/>
-          </a:bodyPr>
-          <a:lstStyle/>
-          <a:p>
-            <a:r>
-              <a:rPr sz="2400" b="1">
-                <a:solidFill>
-                  <a:srgbClr val="FFFFFF"/>
-                </a:solidFill>
-                <a:latin typeface="Times New Roman"/>
-              </a:rPr>
-              <a:t>System architecture (repository-aligned)</a:t>
-            </a:r>
-          </a:p>
-        </p:txBody>
-      </p:sp>
-      <p:sp>
-        <p:nvSpPr>
-          <p:cNvPr id="3" name="TextBox 2"/>
-          <p:cNvSpPr txBox="1"/>
-          <p:nvPr/>
-        </p:nvSpPr>
-        <p:spPr>
-          <a:xfrm>
-            <a:off x="594360" y="960120"/>
-            <a:ext cx="10972800" cy="960120"/>
-          </a:xfrm>
-          <a:prstGeom prst="rect">
-            <a:avLst/>
-          </a:prstGeom>
-          <a:noFill/>
-        </p:spPr>
-        <p:txBody>
-          <a:bodyPr wrap="none">
-            <a:spAutoFit/>
-          </a:bodyPr>
-          <a:lstStyle/>
-          <a:p>
-            <a:pPr>
-              <a:spcAft>
-                <a:spcPts val="600"/>
-              </a:spcAft>
-            </a:pPr>
-            <a:r>
-              <a:rPr sz="1250" b="0">
-                <a:solidFill>
-                  <a:srgbClr val="C8D2E1"/>
-                </a:solidFill>
-                <a:latin typeface="Times New Roman"/>
-              </a:rPr>
-              <a:t>Flow: Clinician → Next.js 14 (TypeScript, Tailwind, Axios) ↔ nginx TLS → FastAPI + Uvicorn (JWT Bearer on protected routes)</a:t>
-            </a:r>
-          </a:p>
-          <a:p>
-            <a:pPr>
-              <a:spcAft>
-                <a:spcPts val="600"/>
-              </a:spcAft>
-            </a:pPr>
-            <a:r>
-              <a:rPr sz="1250" b="0">
-                <a:solidFill>
-                  <a:srgbClr val="C8D2E1"/>
-                </a:solidFill>
-                <a:latin typeface="Times New Roman"/>
-              </a:rPr>
-              <a:t>Inference path: preprocess → ECGFeatureExtractor → torch CNN-BiLSTM → Grad-CAM + SHAP-style features → SQLAlchemy → SQLite</a:t>
-            </a:r>
-          </a:p>
-          <a:p>
-            <a:pPr>
-              <a:spcAft>
-                <a:spcPts val="600"/>
-              </a:spcAft>
-            </a:pPr>
-            <a:r>
-              <a:rPr sz="1250" b="0">
-                <a:solidFill>
-                  <a:srgbClr val="C8D2E1"/>
-                </a:solidFill>
-                <a:latin typeface="Times New Roman"/>
-              </a:rPr>
-              <a:t>Observability: Prometheus scrapes GET /metrics · Grafana datasource http://prometheus:9090 · compose stack in docker-compose.production.yml</a:t>
-            </a:r>
-          </a:p>
-        </p:txBody>
-      </p:sp>
-      <p:sp>
-        <p:nvSpPr>
-          <p:cNvPr id="4" name="Rectangle 3"/>
+          <p:cNvPr id="2" name="Rectangle 1"/>
           <p:cNvSpPr/>
           <p:nvPr/>
         </p:nvSpPr>
         <p:spPr>
           <a:xfrm>
-            <a:off x="914400" y="2331720"/>
-            <a:ext cx="1417320" cy="566928"/>
+            <a:off x="0" y="347472"/>
+            <a:ext cx="12191999" cy="54864"/>
           </a:xfrm>
           <a:prstGeom prst="rect">
             <a:avLst/>
           </a:prstGeom>
           <a:solidFill>
-            <a:srgbClr val="1B263B"/>
+            <a:srgbClr val="2A9D8F"/>
           </a:solidFill>
-          <a:ln w="12700">
-            <a:solidFill>
-              <a:srgbClr val="A8DADC"/>
-            </a:solidFill>
+          <a:ln>
+            <a:noFill/>
           </a:ln>
         </p:spPr>
         <p:style>
@@ -5288,742 +4720,101 @@
           <a:lstStyle/>
           <a:p>
             <a:pPr algn="ctr"/>
-            <a:r>
-              <a:rPr sz="1050" b="0">
+          </a:p>
+        </p:txBody>
+      </p:sp>
+      <p:sp>
+        <p:nvSpPr>
+          <p:cNvPr id="3" name="TextBox 2"/>
+          <p:cNvSpPr txBox="1"/>
+          <p:nvPr/>
+        </p:nvSpPr>
+        <p:spPr>
+          <a:xfrm>
+            <a:off x="502920" y="475488"/>
+            <a:ext cx="11155680" cy="822960"/>
+          </a:xfrm>
+          <a:prstGeom prst="rect">
+            <a:avLst/>
+          </a:prstGeom>
+          <a:noFill/>
+        </p:spPr>
+        <p:txBody>
+          <a:bodyPr wrap="none">
+            <a:spAutoFit/>
+          </a:bodyPr>
+          <a:lstStyle/>
+          <a:p>
+            <a:r>
+              <a:rPr sz="2800" b="1">
                 <a:solidFill>
                   <a:srgbClr val="FFFFFF"/>
                 </a:solidFill>
                 <a:latin typeface="Times New Roman"/>
               </a:rPr>
-              <a:t>User</a:t>
-            </a:r>
-            <a:br/>
-            <a:r>
-              <a:t>(browser)</a:t>
-            </a:r>
-          </a:p>
-        </p:txBody>
-      </p:sp>
-      <p:sp>
-        <p:nvSpPr>
-          <p:cNvPr id="5" name="Rectangle 4"/>
-          <p:cNvSpPr/>
+              <a:t>System architecture — deployed CDS topology</a:t>
+            </a:r>
+          </a:p>
+        </p:txBody>
+      </p:sp>
+      <p:sp>
+        <p:nvSpPr>
+          <p:cNvPr id="4" name="TextBox 3"/>
+          <p:cNvSpPr txBox="1"/>
           <p:nvPr/>
         </p:nvSpPr>
         <p:spPr>
           <a:xfrm>
-            <a:off x="2788920" y="2331720"/>
-            <a:ext cx="1691640" cy="566928"/>
-          </a:xfrm>
-          <a:prstGeom prst="rect">
-            <a:avLst/>
-          </a:prstGeom>
-          <a:solidFill>
-            <a:srgbClr val="1B263B"/>
-          </a:solidFill>
-          <a:ln w="12700">
-            <a:solidFill>
-              <a:srgbClr val="A8DADC"/>
-            </a:solidFill>
-          </a:ln>
-        </p:spPr>
-        <p:style>
-          <a:lnRef idx="1">
-            <a:schemeClr val="accent1"/>
-          </a:lnRef>
-          <a:fillRef idx="3">
-            <a:schemeClr val="accent1"/>
-          </a:fillRef>
-          <a:effectRef idx="2">
-            <a:schemeClr val="accent1"/>
-          </a:effectRef>
-          <a:fontRef idx="minor">
-            <a:schemeClr val="lt1"/>
-          </a:fontRef>
-        </p:style>
-        <p:txBody>
-          <a:bodyPr rtlCol="0" anchor="ctr"/>
-          <a:lstStyle/>
-          <a:p>
-            <a:pPr algn="ctr"/>
-            <a:r>
-              <a:rPr sz="1050" b="0">
+            <a:off x="548640" y="987552"/>
+            <a:ext cx="10972800" cy="411480"/>
+          </a:xfrm>
+          <a:prstGeom prst="rect">
+            <a:avLst/>
+          </a:prstGeom>
+          <a:noFill/>
+        </p:spPr>
+        <p:txBody>
+          <a:bodyPr wrap="none">
+            <a:spAutoFit/>
+          </a:bodyPr>
+          <a:lstStyle/>
+          <a:p>
+            <a:r>
+              <a:rPr sz="1200" b="0">
                 <a:solidFill>
-                  <a:srgbClr val="FFFFFF"/>
+                  <a:srgbClr val="C6D0E0"/>
                 </a:solidFill>
-                <a:latin typeface="Times New Roman"/>
+                <a:latin typeface="Calibri"/>
               </a:rPr>
-              <a:t>Next.js 14</a:t>
-            </a:r>
-            <a:br/>
-            <a:r>
-              <a:t>frontend</a:t>
-            </a:r>
-          </a:p>
-        </p:txBody>
-      </p:sp>
-      <p:sp>
-        <p:nvSpPr>
-          <p:cNvPr id="6" name="Rectangle 5"/>
-          <p:cNvSpPr/>
+              <a:t>Single coherent diagram: user path, inference stack, auth, observability, and container footprint.</a:t>
+            </a:r>
+          </a:p>
+        </p:txBody>
+      </p:sp>
+      <p:pic>
+        <p:nvPicPr>
+          <p:cNvPr id="5" name="Picture 4" descr="tmp64srgbt6.png"/>
+          <p:cNvPicPr>
+            <a:picLocks noChangeAspect="1"/>
+          </p:cNvPicPr>
           <p:nvPr/>
-        </p:nvSpPr>
-        <p:spPr>
-          <a:xfrm>
-            <a:off x="4892040" y="2331720"/>
-            <a:ext cx="1417320" cy="566928"/>
-          </a:xfrm>
-          <a:prstGeom prst="rect">
-            <a:avLst/>
-          </a:prstGeom>
-          <a:solidFill>
-            <a:srgbClr val="1B263B"/>
-          </a:solidFill>
-          <a:ln w="12700">
-            <a:solidFill>
-              <a:srgbClr val="A8DADC"/>
-            </a:solidFill>
-          </a:ln>
-        </p:spPr>
-        <p:style>
-          <a:lnRef idx="1">
-            <a:schemeClr val="accent1"/>
-          </a:lnRef>
-          <a:fillRef idx="3">
-            <a:schemeClr val="accent1"/>
-          </a:fillRef>
-          <a:effectRef idx="2">
-            <a:schemeClr val="accent1"/>
-          </a:effectRef>
-          <a:fontRef idx="minor">
-            <a:schemeClr val="lt1"/>
-          </a:fontRef>
-        </p:style>
-        <p:txBody>
-          <a:bodyPr rtlCol="0" anchor="ctr"/>
-          <a:lstStyle/>
-          <a:p>
-            <a:pPr algn="ctr"/>
-            <a:r>
-              <a:rPr sz="1050" b="0">
-                <a:solidFill>
-                  <a:srgbClr val="FFFFFF"/>
-                </a:solidFill>
-                <a:latin typeface="Times New Roman"/>
-              </a:rPr>
-              <a:t>nginx</a:t>
-            </a:r>
-            <a:br/>
-            <a:r>
-              <a:t>reverse proxy</a:t>
-            </a:r>
-          </a:p>
-        </p:txBody>
-      </p:sp>
-      <p:sp>
-        <p:nvSpPr>
-          <p:cNvPr id="7" name="Rectangle 6"/>
-          <p:cNvSpPr/>
-          <p:nvPr/>
-        </p:nvSpPr>
-        <p:spPr>
-          <a:xfrm>
-            <a:off x="6720840" y="2331720"/>
-            <a:ext cx="1691640" cy="566928"/>
-          </a:xfrm>
-          <a:prstGeom prst="rect">
-            <a:avLst/>
-          </a:prstGeom>
-          <a:solidFill>
-            <a:srgbClr val="1B263B"/>
-          </a:solidFill>
-          <a:ln w="12700">
-            <a:solidFill>
-              <a:srgbClr val="A8DADC"/>
-            </a:solidFill>
-          </a:ln>
-        </p:spPr>
-        <p:style>
-          <a:lnRef idx="1">
-            <a:schemeClr val="accent1"/>
-          </a:lnRef>
-          <a:fillRef idx="3">
-            <a:schemeClr val="accent1"/>
-          </a:fillRef>
-          <a:effectRef idx="2">
-            <a:schemeClr val="accent1"/>
-          </a:effectRef>
-          <a:fontRef idx="minor">
-            <a:schemeClr val="lt1"/>
-          </a:fontRef>
-        </p:style>
-        <p:txBody>
-          <a:bodyPr rtlCol="0" anchor="ctr"/>
-          <a:lstStyle/>
-          <a:p>
-            <a:pPr algn="ctr"/>
-            <a:r>
-              <a:rPr sz="1050" b="0">
-                <a:solidFill>
-                  <a:srgbClr val="FFFFFF"/>
-                </a:solidFill>
-                <a:latin typeface="Times New Roman"/>
-              </a:rPr>
-              <a:t>FastAPI</a:t>
-            </a:r>
-            <a:br/>
-            <a:r>
-              <a:t>(Uvicorn)</a:t>
-            </a:r>
-          </a:p>
-        </p:txBody>
-      </p:sp>
-      <p:sp>
-        <p:nvSpPr>
-          <p:cNvPr id="8" name="Rectangle 7"/>
-          <p:cNvSpPr/>
-          <p:nvPr/>
-        </p:nvSpPr>
-        <p:spPr>
-          <a:xfrm>
-            <a:off x="8823960" y="2331720"/>
-            <a:ext cx="1417320" cy="566928"/>
-          </a:xfrm>
-          <a:prstGeom prst="rect">
-            <a:avLst/>
-          </a:prstGeom>
-          <a:solidFill>
-            <a:srgbClr val="1B263B"/>
-          </a:solidFill>
-          <a:ln w="12700">
-            <a:solidFill>
-              <a:srgbClr val="A8DADC"/>
-            </a:solidFill>
-          </a:ln>
-        </p:spPr>
-        <p:style>
-          <a:lnRef idx="1">
-            <a:schemeClr val="accent1"/>
-          </a:lnRef>
-          <a:fillRef idx="3">
-            <a:schemeClr val="accent1"/>
-          </a:fillRef>
-          <a:effectRef idx="2">
-            <a:schemeClr val="accent1"/>
-          </a:effectRef>
-          <a:fontRef idx="minor">
-            <a:schemeClr val="lt1"/>
-          </a:fontRef>
-        </p:style>
-        <p:txBody>
-          <a:bodyPr rtlCol="0" anchor="ctr"/>
-          <a:lstStyle/>
-          <a:p>
-            <a:pPr algn="ctr"/>
-            <a:r>
-              <a:rPr sz="1050" b="0">
-                <a:solidFill>
-                  <a:srgbClr val="FFFFFF"/>
-                </a:solidFill>
-                <a:latin typeface="Times New Roman"/>
-              </a:rPr>
-              <a:t>JWT auth</a:t>
-            </a:r>
-            <a:br/>
-            <a:r>
-              <a:t>OTP email</a:t>
-            </a:r>
-          </a:p>
-        </p:txBody>
-      </p:sp>
-      <p:sp>
-        <p:nvSpPr>
-          <p:cNvPr id="9" name="Rectangle 8"/>
-          <p:cNvSpPr/>
-          <p:nvPr/>
-        </p:nvSpPr>
-        <p:spPr>
-          <a:xfrm>
-            <a:off x="1600200" y="3611880"/>
-            <a:ext cx="1874519" cy="566928"/>
-          </a:xfrm>
-          <a:prstGeom prst="rect">
-            <a:avLst/>
-          </a:prstGeom>
-          <a:solidFill>
-            <a:srgbClr val="1B263B"/>
-          </a:solidFill>
-          <a:ln w="12700">
-            <a:solidFill>
-              <a:srgbClr val="A8DADC"/>
-            </a:solidFill>
-          </a:ln>
-        </p:spPr>
-        <p:style>
-          <a:lnRef idx="1">
-            <a:schemeClr val="accent1"/>
-          </a:lnRef>
-          <a:fillRef idx="3">
-            <a:schemeClr val="accent1"/>
-          </a:fillRef>
-          <a:effectRef idx="2">
-            <a:schemeClr val="accent1"/>
-          </a:effectRef>
-          <a:fontRef idx="minor">
-            <a:schemeClr val="lt1"/>
-          </a:fontRef>
-        </p:style>
-        <p:txBody>
-          <a:bodyPr rtlCol="0" anchor="ctr"/>
-          <a:lstStyle/>
-          <a:p>
-            <a:pPr algn="ctr"/>
-            <a:r>
-              <a:rPr sz="1050" b="0">
-                <a:solidFill>
-                  <a:srgbClr val="FFFFFF"/>
-                </a:solidFill>
-                <a:latin typeface="Times New Roman"/>
-              </a:rPr>
-              <a:t>Preproc +</a:t>
-            </a:r>
-            <a:br/>
-            <a:r>
-              <a:t>Pan–Tompkins</a:t>
-            </a:r>
-          </a:p>
-        </p:txBody>
-      </p:sp>
-      <p:sp>
-        <p:nvSpPr>
-          <p:cNvPr id="10" name="Rectangle 9"/>
-          <p:cNvSpPr/>
-          <p:nvPr/>
-        </p:nvSpPr>
-        <p:spPr>
-          <a:xfrm>
-            <a:off x="3977639" y="3611880"/>
-            <a:ext cx="1783080" cy="566928"/>
-          </a:xfrm>
-          <a:prstGeom prst="rect">
-            <a:avLst/>
-          </a:prstGeom>
-          <a:solidFill>
-            <a:srgbClr val="1B263B"/>
-          </a:solidFill>
-          <a:ln w="12700">
-            <a:solidFill>
-              <a:srgbClr val="A8DADC"/>
-            </a:solidFill>
-          </a:ln>
-        </p:spPr>
-        <p:style>
-          <a:lnRef idx="1">
-            <a:schemeClr val="accent1"/>
-          </a:lnRef>
-          <a:fillRef idx="3">
-            <a:schemeClr val="accent1"/>
-          </a:fillRef>
-          <a:effectRef idx="2">
-            <a:schemeClr val="accent1"/>
-          </a:effectRef>
-          <a:fontRef idx="minor">
-            <a:schemeClr val="lt1"/>
-          </a:fontRef>
-        </p:style>
-        <p:txBody>
-          <a:bodyPr rtlCol="0" anchor="ctr"/>
-          <a:lstStyle/>
-          <a:p>
-            <a:pPr algn="ctr"/>
-            <a:r>
-              <a:rPr sz="1050" b="0">
-                <a:solidFill>
-                  <a:srgbClr val="FFFFFF"/>
-                </a:solidFill>
-                <a:latin typeface="Times New Roman"/>
-              </a:rPr>
-              <a:t>Features +</a:t>
-            </a:r>
-            <a:br/>
-            <a:r>
-              <a:t>Torch model</a:t>
-            </a:r>
-          </a:p>
-        </p:txBody>
-      </p:sp>
-      <p:sp>
-        <p:nvSpPr>
-          <p:cNvPr id="11" name="Rectangle 10"/>
-          <p:cNvSpPr/>
-          <p:nvPr/>
-        </p:nvSpPr>
-        <p:spPr>
-          <a:xfrm>
-            <a:off x="6172200" y="3611880"/>
-            <a:ext cx="1691640" cy="566928"/>
-          </a:xfrm>
-          <a:prstGeom prst="rect">
-            <a:avLst/>
-          </a:prstGeom>
-          <a:solidFill>
-            <a:srgbClr val="1B263B"/>
-          </a:solidFill>
-          <a:ln w="12700">
-            <a:solidFill>
-              <a:srgbClr val="A8DADC"/>
-            </a:solidFill>
-          </a:ln>
-        </p:spPr>
-        <p:style>
-          <a:lnRef idx="1">
-            <a:schemeClr val="accent1"/>
-          </a:lnRef>
-          <a:fillRef idx="3">
-            <a:schemeClr val="accent1"/>
-          </a:fillRef>
-          <a:effectRef idx="2">
-            <a:schemeClr val="accent1"/>
-          </a:effectRef>
-          <a:fontRef idx="minor">
-            <a:schemeClr val="lt1"/>
-          </a:fontRef>
-        </p:style>
-        <p:txBody>
-          <a:bodyPr rtlCol="0" anchor="ctr"/>
-          <a:lstStyle/>
-          <a:p>
-            <a:pPr algn="ctr"/>
-            <a:r>
-              <a:rPr sz="1050" b="0">
-                <a:solidFill>
-                  <a:srgbClr val="FFFFFF"/>
-                </a:solidFill>
-                <a:latin typeface="Times New Roman"/>
-              </a:rPr>
-              <a:t>XAI</a:t>
-            </a:r>
-            <a:br/>
-            <a:r>
-              <a:t>Grad-CAM · SHAP</a:t>
-            </a:r>
-          </a:p>
-        </p:txBody>
-      </p:sp>
-      <p:sp>
-        <p:nvSpPr>
-          <p:cNvPr id="12" name="Rectangle 11"/>
-          <p:cNvSpPr/>
-          <p:nvPr/>
-        </p:nvSpPr>
-        <p:spPr>
-          <a:xfrm>
-            <a:off x="8275320" y="3611880"/>
-            <a:ext cx="1417320" cy="566928"/>
-          </a:xfrm>
-          <a:prstGeom prst="rect">
-            <a:avLst/>
-          </a:prstGeom>
-          <a:solidFill>
-            <a:srgbClr val="1B263B"/>
-          </a:solidFill>
-          <a:ln w="12700">
-            <a:solidFill>
-              <a:srgbClr val="A8DADC"/>
-            </a:solidFill>
-          </a:ln>
-        </p:spPr>
-        <p:style>
-          <a:lnRef idx="1">
-            <a:schemeClr val="accent1"/>
-          </a:lnRef>
-          <a:fillRef idx="3">
-            <a:schemeClr val="accent1"/>
-          </a:fillRef>
-          <a:effectRef idx="2">
-            <a:schemeClr val="accent1"/>
-          </a:effectRef>
-          <a:fontRef idx="minor">
-            <a:schemeClr val="lt1"/>
-          </a:fontRef>
-        </p:style>
-        <p:txBody>
-          <a:bodyPr rtlCol="0" anchor="ctr"/>
-          <a:lstStyle/>
-          <a:p>
-            <a:pPr algn="ctr"/>
-            <a:r>
-              <a:rPr sz="1050" b="0">
-                <a:solidFill>
-                  <a:srgbClr val="FFFFFF"/>
-                </a:solidFill>
-                <a:latin typeface="Times New Roman"/>
-              </a:rPr>
-              <a:t>SQLite +</a:t>
-            </a:r>
-            <a:br/>
-            <a:r>
-              <a:t>SQLAlchemy</a:t>
-            </a:r>
-          </a:p>
-        </p:txBody>
-      </p:sp>
-      <p:sp>
-        <p:nvSpPr>
-          <p:cNvPr id="13" name="Rectangle 12"/>
-          <p:cNvSpPr/>
-          <p:nvPr/>
-        </p:nvSpPr>
-        <p:spPr>
-          <a:xfrm>
-            <a:off x="3246120" y="4892040"/>
-            <a:ext cx="2331720" cy="566928"/>
-          </a:xfrm>
-          <a:prstGeom prst="rect">
-            <a:avLst/>
-          </a:prstGeom>
-          <a:solidFill>
-            <a:srgbClr val="1B263B"/>
-          </a:solidFill>
-          <a:ln w="12700">
-            <a:solidFill>
-              <a:srgbClr val="A8DADC"/>
-            </a:solidFill>
-          </a:ln>
-        </p:spPr>
-        <p:style>
-          <a:lnRef idx="1">
-            <a:schemeClr val="accent1"/>
-          </a:lnRef>
-          <a:fillRef idx="3">
-            <a:schemeClr val="accent1"/>
-          </a:fillRef>
-          <a:effectRef idx="2">
-            <a:schemeClr val="accent1"/>
-          </a:effectRef>
-          <a:fontRef idx="minor">
-            <a:schemeClr val="lt1"/>
-          </a:fontRef>
-        </p:style>
-        <p:txBody>
-          <a:bodyPr rtlCol="0" anchor="ctr"/>
-          <a:lstStyle/>
-          <a:p>
-            <a:pPr algn="ctr"/>
-            <a:r>
-              <a:rPr sz="1050" b="0">
-                <a:solidFill>
-                  <a:srgbClr val="FFFFFF"/>
-                </a:solidFill>
-                <a:latin typeface="Times New Roman"/>
-              </a:rPr>
-              <a:t>Prometheus → Grafana</a:t>
-            </a:r>
-            <a:br/>
-            <a:r>
-              <a:t>(localhost / tunnel)</a:t>
-            </a:r>
-          </a:p>
-        </p:txBody>
-      </p:sp>
-      <p:sp>
-        <p:nvSpPr>
-          <p:cNvPr id="14" name="Rectangle 13"/>
-          <p:cNvSpPr/>
-          <p:nvPr/>
-        </p:nvSpPr>
-        <p:spPr>
-          <a:xfrm>
-            <a:off x="6263640" y="4892040"/>
-            <a:ext cx="1874519" cy="566928"/>
-          </a:xfrm>
-          <a:prstGeom prst="rect">
-            <a:avLst/>
-          </a:prstGeom>
-          <a:solidFill>
-            <a:srgbClr val="1B263B"/>
-          </a:solidFill>
-          <a:ln w="12700">
-            <a:solidFill>
-              <a:srgbClr val="A8DADC"/>
-            </a:solidFill>
-          </a:ln>
-        </p:spPr>
-        <p:style>
-          <a:lnRef idx="1">
-            <a:schemeClr val="accent1"/>
-          </a:lnRef>
-          <a:fillRef idx="3">
-            <a:schemeClr val="accent1"/>
-          </a:fillRef>
-          <a:effectRef idx="2">
-            <a:schemeClr val="accent1"/>
-          </a:effectRef>
-          <a:fontRef idx="minor">
-            <a:schemeClr val="lt1"/>
-          </a:fontRef>
-        </p:style>
-        <p:txBody>
-          <a:bodyPr rtlCol="0" anchor="ctr"/>
-          <a:lstStyle/>
-          <a:p>
-            <a:pPr algn="ctr"/>
-            <a:r>
-              <a:rPr sz="1050" b="0">
-                <a:solidFill>
-                  <a:srgbClr val="FFFFFF"/>
-                </a:solidFill>
-                <a:latin typeface="Times New Roman"/>
-              </a:rPr>
-              <a:t>AWS EC2 +</a:t>
-            </a:r>
-            <a:br/>
-            <a:r>
-              <a:t>Docker Compose</a:t>
-            </a:r>
-          </a:p>
-        </p:txBody>
-      </p:sp>
-      <p:cxnSp>
-        <p:nvCxnSpPr>
-          <p:cNvPr id="15" name="Connector 14"/>
-          <p:cNvCxnSpPr/>
-          <p:nvPr/>
-        </p:nvCxnSpPr>
-        <p:spPr>
-          <a:xfrm>
-            <a:off x="2359152" y="2615184"/>
-            <a:ext cx="402336" cy="0"/>
-          </a:xfrm>
-          <a:prstGeom prst="line">
-            <a:avLst/>
-          </a:prstGeom>
-          <a:ln w="15875">
-            <a:solidFill>
-              <a:srgbClr val="C8D2E1"/>
-            </a:solidFill>
-          </a:ln>
-        </p:spPr>
-        <p:style>
-          <a:lnRef idx="2">
-            <a:schemeClr val="accent1"/>
-          </a:lnRef>
-          <a:fillRef idx="0">
-            <a:schemeClr val="accent1"/>
-          </a:fillRef>
-          <a:effectRef idx="1">
-            <a:schemeClr val="accent1"/>
-          </a:effectRef>
-          <a:fontRef idx="minor">
-            <a:schemeClr val="tx1"/>
-          </a:fontRef>
-        </p:style>
-      </p:cxnSp>
-      <p:cxnSp>
-        <p:nvCxnSpPr>
-          <p:cNvPr id="16" name="Connector 15"/>
-          <p:cNvCxnSpPr/>
-          <p:nvPr/>
-        </p:nvCxnSpPr>
-        <p:spPr>
-          <a:xfrm>
-            <a:off x="4507992" y="2615184"/>
-            <a:ext cx="365760" cy="0"/>
-          </a:xfrm>
-          <a:prstGeom prst="line">
-            <a:avLst/>
-          </a:prstGeom>
-          <a:ln w="15875">
-            <a:solidFill>
-              <a:srgbClr val="C8D2E1"/>
-            </a:solidFill>
-          </a:ln>
-        </p:spPr>
-        <p:style>
-          <a:lnRef idx="2">
-            <a:schemeClr val="accent1"/>
-          </a:lnRef>
-          <a:fillRef idx="0">
-            <a:schemeClr val="accent1"/>
-          </a:fillRef>
-          <a:effectRef idx="1">
-            <a:schemeClr val="accent1"/>
-          </a:effectRef>
-          <a:fontRef idx="minor">
-            <a:schemeClr val="tx1"/>
-          </a:fontRef>
-        </p:style>
-      </p:cxnSp>
-      <p:cxnSp>
-        <p:nvCxnSpPr>
-          <p:cNvPr id="17" name="Connector 16"/>
-          <p:cNvCxnSpPr/>
-          <p:nvPr/>
-        </p:nvCxnSpPr>
-        <p:spPr>
-          <a:xfrm>
-            <a:off x="6336792" y="2615184"/>
-            <a:ext cx="356616" cy="0"/>
-          </a:xfrm>
-          <a:prstGeom prst="line">
-            <a:avLst/>
-          </a:prstGeom>
-          <a:ln w="15875">
-            <a:solidFill>
-              <a:srgbClr val="C8D2E1"/>
-            </a:solidFill>
-          </a:ln>
-        </p:spPr>
-        <p:style>
-          <a:lnRef idx="2">
-            <a:schemeClr val="accent1"/>
-          </a:lnRef>
-          <a:fillRef idx="0">
-            <a:schemeClr val="accent1"/>
-          </a:fillRef>
-          <a:effectRef idx="1">
-            <a:schemeClr val="accent1"/>
-          </a:effectRef>
-          <a:fontRef idx="minor">
-            <a:schemeClr val="tx1"/>
-          </a:fontRef>
-        </p:style>
-      </p:cxnSp>
-      <p:cxnSp>
-        <p:nvCxnSpPr>
-          <p:cNvPr id="18" name="Connector 17"/>
-          <p:cNvCxnSpPr/>
-          <p:nvPr/>
-        </p:nvCxnSpPr>
-        <p:spPr>
-          <a:xfrm>
-            <a:off x="8439912" y="2615184"/>
-            <a:ext cx="356616" cy="0"/>
-          </a:xfrm>
-          <a:prstGeom prst="line">
-            <a:avLst/>
-          </a:prstGeom>
-          <a:ln w="15875">
-            <a:solidFill>
-              <a:srgbClr val="C8D2E1"/>
-            </a:solidFill>
-          </a:ln>
-        </p:spPr>
-        <p:style>
-          <a:lnRef idx="2">
-            <a:schemeClr val="accent1"/>
-          </a:lnRef>
-          <a:fillRef idx="0">
-            <a:schemeClr val="accent1"/>
-          </a:fillRef>
-          <a:effectRef idx="1">
-            <a:schemeClr val="accent1"/>
-          </a:effectRef>
-          <a:fontRef idx="minor">
-            <a:schemeClr val="tx1"/>
-          </a:fontRef>
-        </p:style>
-      </p:cxnSp>
+        </p:nvPicPr>
+        <p:blipFill>
+          <a:blip r:embed="rId2"/>
+          <a:stretch>
+            <a:fillRect/>
+          </a:stretch>
+        </p:blipFill>
+        <p:spPr>
+          <a:xfrm>
+            <a:off x="411480" y="1389888"/>
+            <a:ext cx="11384280" cy="5884421"/>
+          </a:xfrm>
+          <a:prstGeom prst="rect">
+            <a:avLst/>
+          </a:prstGeom>
+        </p:spPr>
+      </p:pic>
     </p:spTree>
   </p:cSld>
   <p:clrMapOvr>
@@ -6052,14 +4843,57 @@
       <p:grpSpPr/>
       <p:sp>
         <p:nvSpPr>
-          <p:cNvPr id="2" name="TextBox 1"/>
+          <p:cNvPr id="2" name="Rectangle 1"/>
+          <p:cNvSpPr/>
+          <p:nvPr/>
+        </p:nvSpPr>
+        <p:spPr>
+          <a:xfrm>
+            <a:off x="0" y="347472"/>
+            <a:ext cx="12191999" cy="54864"/>
+          </a:xfrm>
+          <a:prstGeom prst="rect">
+            <a:avLst/>
+          </a:prstGeom>
+          <a:solidFill>
+            <a:srgbClr val="2A9D8F"/>
+          </a:solidFill>
+          <a:ln>
+            <a:noFill/>
+          </a:ln>
+        </p:spPr>
+        <p:style>
+          <a:lnRef idx="1">
+            <a:schemeClr val="accent1"/>
+          </a:lnRef>
+          <a:fillRef idx="3">
+            <a:schemeClr val="accent1"/>
+          </a:fillRef>
+          <a:effectRef idx="2">
+            <a:schemeClr val="accent1"/>
+          </a:effectRef>
+          <a:fontRef idx="minor">
+            <a:schemeClr val="lt1"/>
+          </a:fontRef>
+        </p:style>
+        <p:txBody>
+          <a:bodyPr rtlCol="0" anchor="ctr"/>
+          <a:lstStyle/>
+          <a:p>
+            <a:pPr algn="ctr"/>
+          </a:p>
+        </p:txBody>
+      </p:sp>
+      <p:sp>
+        <p:nvSpPr>
+          <p:cNvPr id="3" name="TextBox 2"/>
           <p:cNvSpPr txBox="1"/>
           <p:nvPr/>
         </p:nvSpPr>
         <p:spPr>
           <a:xfrm>
-            <a:off x="502920" y="320040"/>
-            <a:ext cx="10972800" cy="685800"/>
+            <a:off x="502920" y="475488"/>
+            <a:ext cx="11155680" cy="822960"/>
           </a:xfrm>
           <a:prstGeom prst="rect">
             <a:avLst/>
@@ -6073,20 +4907,54 @@
           <a:lstStyle/>
           <a:p>
             <a:r>
-              <a:rPr sz="2400" b="1">
+              <a:rPr sz="2800" b="1">
                 <a:solidFill>
                   <a:srgbClr val="FFFFFF"/>
                 </a:solidFill>
                 <a:latin typeface="Times New Roman"/>
               </a:rPr>
-              <a:t>ECG signal processing pipeline</a:t>
+              <a:t>ECG signal processing &amp; model inputs</a:t>
+            </a:r>
+          </a:p>
+        </p:txBody>
+      </p:sp>
+      <p:sp>
+        <p:nvSpPr>
+          <p:cNvPr id="4" name="TextBox 3"/>
+          <p:cNvSpPr txBox="1"/>
+          <p:nvPr/>
+        </p:nvSpPr>
+        <p:spPr>
+          <a:xfrm>
+            <a:off x="548640" y="987552"/>
+            <a:ext cx="10972800" cy="411480"/>
+          </a:xfrm>
+          <a:prstGeom prst="rect">
+            <a:avLst/>
+          </a:prstGeom>
+          <a:noFill/>
+        </p:spPr>
+        <p:txBody>
+          <a:bodyPr wrap="none">
+            <a:spAutoFit/>
+          </a:bodyPr>
+          <a:lstStyle/>
+          <a:p>
+            <a:r>
+              <a:rPr sz="1200" b="0">
+                <a:solidFill>
+                  <a:srgbClr val="C6D0E0"/>
+                </a:solidFill>
+                <a:latin typeface="Calibri"/>
+              </a:rPr>
+              <a:t>Pan–Tompkins · bandpass/notch · median beat · Daubechies features — matches backend/preprocessing.py and features.py.</a:t>
             </a:r>
           </a:p>
         </p:txBody>
       </p:sp>
       <p:pic>
         <p:nvPicPr>
-          <p:cNvPr id="3" name="Picture 2" descr="tmp1x86g2nf.png"/>
+          <p:cNvPr id="5" name="Picture 4" descr="tmpjmvke1wc.png"/>
           <p:cNvPicPr>
             <a:picLocks noChangeAspect="1"/>
           </p:cNvPicPr>
@@ -6100,48 +4968,14 @@
         </p:blipFill>
         <p:spPr>
           <a:xfrm>
-            <a:off x="594360" y="960120"/>
-            <a:ext cx="11064240" cy="4675735"/>
+            <a:off x="411480" y="1389888"/>
+            <a:ext cx="11384280" cy="5294651"/>
           </a:xfrm>
           <a:prstGeom prst="rect">
             <a:avLst/>
           </a:prstGeom>
         </p:spPr>
       </p:pic>
-      <p:sp>
-        <p:nvSpPr>
-          <p:cNvPr id="4" name="TextBox 3"/>
-          <p:cNvSpPr txBox="1"/>
-          <p:nvPr/>
-        </p:nvSpPr>
-        <p:spPr>
-          <a:xfrm>
-            <a:off x="594360" y="6263640"/>
-            <a:ext cx="10972800" cy="502920"/>
-          </a:xfrm>
-          <a:prstGeom prst="rect">
-            <a:avLst/>
-          </a:prstGeom>
-          <a:noFill/>
-        </p:spPr>
-        <p:txBody>
-          <a:bodyPr wrap="none">
-            <a:spAutoFit/>
-          </a:bodyPr>
-          <a:lstStyle/>
-          <a:p>
-            <a:r>
-              <a:rPr sz="1100" b="0">
-                <a:solidFill>
-                  <a:srgbClr val="C8D2E1"/>
-                </a:solidFill>
-                <a:latin typeface="Times New Roman"/>
-              </a:rPr>
-              <a:t>NeuroKit2-backed Pan–Tompkins when available; SciPy Butterworth bandpass + notch per preprocessing.py.</a:t>
-            </a:r>
-          </a:p>
-        </p:txBody>
-      </p:sp>
     </p:spTree>
   </p:cSld>
   <p:clrMapOvr>
@@ -6170,14 +5004,57 @@
       <p:grpSpPr/>
       <p:sp>
         <p:nvSpPr>
-          <p:cNvPr id="2" name="TextBox 1"/>
+          <p:cNvPr id="2" name="Rectangle 1"/>
+          <p:cNvSpPr/>
+          <p:nvPr/>
+        </p:nvSpPr>
+        <p:spPr>
+          <a:xfrm>
+            <a:off x="0" y="347472"/>
+            <a:ext cx="12191999" cy="54864"/>
+          </a:xfrm>
+          <a:prstGeom prst="rect">
+            <a:avLst/>
+          </a:prstGeom>
+          <a:solidFill>
+            <a:srgbClr val="2A9D8F"/>
+          </a:solidFill>
+          <a:ln>
+            <a:noFill/>
+          </a:ln>
+        </p:spPr>
+        <p:style>
+          <a:lnRef idx="1">
+            <a:schemeClr val="accent1"/>
+          </a:lnRef>
+          <a:fillRef idx="3">
+            <a:schemeClr val="accent1"/>
+          </a:fillRef>
+          <a:effectRef idx="2">
+            <a:schemeClr val="accent1"/>
+          </a:effectRef>
+          <a:fontRef idx="minor">
+            <a:schemeClr val="lt1"/>
+          </a:fontRef>
+        </p:style>
+        <p:txBody>
+          <a:bodyPr rtlCol="0" anchor="ctr"/>
+          <a:lstStyle/>
+          <a:p>
+            <a:pPr algn="ctr"/>
+          </a:p>
+        </p:txBody>
+      </p:sp>
+      <p:sp>
+        <p:nvSpPr>
+          <p:cNvPr id="3" name="TextBox 2"/>
           <p:cNvSpPr txBox="1"/>
           <p:nvPr/>
         </p:nvSpPr>
         <p:spPr>
           <a:xfrm>
-            <a:off x="502920" y="320040"/>
-            <a:ext cx="10972800" cy="685800"/>
+            <a:off x="502920" y="475488"/>
+            <a:ext cx="11155680" cy="822960"/>
           </a:xfrm>
           <a:prstGeom prst="rect">
             <a:avLst/>
@@ -6191,20 +5068,54 @@
           <a:lstStyle/>
           <a:p>
             <a:r>
-              <a:rPr sz="2400" b="1">
+              <a:rPr sz="2800" b="1">
                 <a:solidFill>
                   <a:srgbClr val="FFFFFF"/>
                 </a:solidFill>
                 <a:latin typeface="Times New Roman"/>
               </a:rPr>
-              <a:t>Deep learning model (CNN–BiLSTM)</a:t>
+              <a:t>CNN–BiLSTM inference graph</a:t>
+            </a:r>
+          </a:p>
+        </p:txBody>
+      </p:sp>
+      <p:sp>
+        <p:nvSpPr>
+          <p:cNvPr id="4" name="TextBox 3"/>
+          <p:cNvSpPr txBox="1"/>
+          <p:nvPr/>
+        </p:nvSpPr>
+        <p:spPr>
+          <a:xfrm>
+            <a:off x="548640" y="987552"/>
+            <a:ext cx="10972800" cy="411480"/>
+          </a:xfrm>
+          <a:prstGeom prst="rect">
+            <a:avLst/>
+          </a:prstGeom>
+          <a:noFill/>
+        </p:spPr>
+        <p:txBody>
+          <a:bodyPr wrap="none">
+            <a:spAutoFit/>
+          </a:bodyPr>
+          <a:lstStyle/>
+          <a:p>
+            <a:r>
+              <a:rPr sz="1200" b="0">
+                <a:solidFill>
+                  <a:srgbClr val="C6D0E0"/>
+                </a:solidFill>
+                <a:latin typeface="Calibri"/>
+              </a:rPr>
+              <a:t>research-grade view of CardioSense dual-branch fusion with concrete STFT hyper-parameters.</a:t>
             </a:r>
           </a:p>
         </p:txBody>
       </p:sp>
       <p:pic>
         <p:nvPicPr>
-          <p:cNvPr id="3" name="Picture 2" descr="tmplwmd7no1.png"/>
+          <p:cNvPr id="5" name="Picture 4" descr="tmpm9d55u90.png"/>
           <p:cNvPicPr>
             <a:picLocks noChangeAspect="1"/>
           </p:cNvPicPr>
@@ -6218,48 +5129,14 @@
         </p:blipFill>
         <p:spPr>
           <a:xfrm>
-            <a:off x="594360" y="960120"/>
-            <a:ext cx="11064240" cy="4712547"/>
+            <a:off x="411480" y="1389888"/>
+            <a:ext cx="11384280" cy="5805501"/>
           </a:xfrm>
           <a:prstGeom prst="rect">
             <a:avLst/>
           </a:prstGeom>
         </p:spPr>
       </p:pic>
-      <p:sp>
-        <p:nvSpPr>
-          <p:cNvPr id="4" name="TextBox 3"/>
-          <p:cNvSpPr txBox="1"/>
-          <p:nvPr/>
-        </p:nvSpPr>
-        <p:spPr>
-          <a:xfrm>
-            <a:off x="594360" y="6263640"/>
-            <a:ext cx="10972800" cy="502920"/>
-          </a:xfrm>
-          <a:prstGeom prst="rect">
-            <a:avLst/>
-          </a:prstGeom>
-          <a:noFill/>
-        </p:spPr>
-        <p:txBody>
-          <a:bodyPr wrap="none">
-            <a:spAutoFit/>
-          </a:bodyPr>
-          <a:lstStyle/>
-          <a:p>
-            <a:r>
-              <a:rPr sz="1100" b="0">
-                <a:solidFill>
-                  <a:srgbClr val="C8D2E1"/>
-                </a:solidFill>
-                <a:latin typeface="Times New Roman"/>
-              </a:rPr>
-              <a:t>Spectrogram CNN branch + temporal BiLSTM + gated fusion; dual sigmoid heads for AMI and revascularization.</a:t>
-            </a:r>
-          </a:p>
-        </p:txBody>
-      </p:sp>
     </p:spTree>
   </p:cSld>
   <p:clrMapOvr>
@@ -6288,14 +5165,57 @@
       <p:grpSpPr/>
       <p:sp>
         <p:nvSpPr>
-          <p:cNvPr id="2" name="TextBox 1"/>
+          <p:cNvPr id="2" name="Rectangle 1"/>
+          <p:cNvSpPr/>
+          <p:nvPr/>
+        </p:nvSpPr>
+        <p:spPr>
+          <a:xfrm>
+            <a:off x="0" y="347472"/>
+            <a:ext cx="12191999" cy="54864"/>
+          </a:xfrm>
+          <a:prstGeom prst="rect">
+            <a:avLst/>
+          </a:prstGeom>
+          <a:solidFill>
+            <a:srgbClr val="2A9D8F"/>
+          </a:solidFill>
+          <a:ln>
+            <a:noFill/>
+          </a:ln>
+        </p:spPr>
+        <p:style>
+          <a:lnRef idx="1">
+            <a:schemeClr val="accent1"/>
+          </a:lnRef>
+          <a:fillRef idx="3">
+            <a:schemeClr val="accent1"/>
+          </a:fillRef>
+          <a:effectRef idx="2">
+            <a:schemeClr val="accent1"/>
+          </a:effectRef>
+          <a:fontRef idx="minor">
+            <a:schemeClr val="lt1"/>
+          </a:fontRef>
+        </p:style>
+        <p:txBody>
+          <a:bodyPr rtlCol="0" anchor="ctr"/>
+          <a:lstStyle/>
+          <a:p>
+            <a:pPr algn="ctr"/>
+          </a:p>
+        </p:txBody>
+      </p:sp>
+      <p:sp>
+        <p:nvSpPr>
+          <p:cNvPr id="3" name="TextBox 2"/>
           <p:cNvSpPr txBox="1"/>
           <p:nvPr/>
         </p:nvSpPr>
         <p:spPr>
           <a:xfrm>
-            <a:off x="502920" y="320040"/>
-            <a:ext cx="10972800" cy="685800"/>
+            <a:off x="502920" y="475488"/>
+            <a:ext cx="11155680" cy="822960"/>
           </a:xfrm>
           <a:prstGeom prst="rect">
             <a:avLst/>
@@ -6309,20 +5229,54 @@
           <a:lstStyle/>
           <a:p>
             <a:r>
-              <a:rPr sz="2400" b="1">
+              <a:rPr sz="2800" b="1">
                 <a:solidFill>
                   <a:srgbClr val="FFFFFF"/>
                 </a:solidFill>
                 <a:latin typeface="Times New Roman"/>
               </a:rPr>
-              <a:t>Explainable AI — Grad-CAM · SHAP-style attribution</a:t>
+              <a:t>Explainable AI — Grad-CAM &amp; SHAP-style outputs</a:t>
+            </a:r>
+          </a:p>
+        </p:txBody>
+      </p:sp>
+      <p:sp>
+        <p:nvSpPr>
+          <p:cNvPr id="4" name="TextBox 3"/>
+          <p:cNvSpPr txBox="1"/>
+          <p:nvPr/>
+        </p:nvSpPr>
+        <p:spPr>
+          <a:xfrm>
+            <a:off x="548640" y="987552"/>
+            <a:ext cx="10972800" cy="411480"/>
+          </a:xfrm>
+          <a:prstGeom prst="rect">
+            <a:avLst/>
+          </a:prstGeom>
+          <a:noFill/>
+        </p:spPr>
+        <p:txBody>
+          <a:bodyPr wrap="none">
+            <a:spAutoFit/>
+          </a:bodyPr>
+          <a:lstStyle/>
+          <a:p>
+            <a:r>
+              <a:rPr sz="1200" b="0">
+                <a:solidFill>
+                  <a:srgbClr val="C6D0E0"/>
+                </a:solidFill>
+                <a:latin typeface="Calibri"/>
+              </a:rPr>
+              <a:t>Illustrative only — API keys: gradcam_lead_importance, shap_features · explain.py + Next.js visualisation.</a:t>
             </a:r>
           </a:p>
         </p:txBody>
       </p:sp>
       <p:pic>
         <p:nvPicPr>
-          <p:cNvPr id="3" name="Picture 2" descr="tmpgjknrhf0.png"/>
+          <p:cNvPr id="5" name="Picture 4" descr="tmpp5jav5wj.png"/>
           <p:cNvPicPr>
             <a:picLocks noChangeAspect="1"/>
           </p:cNvPicPr>
@@ -6336,48 +5290,14 @@
         </p:blipFill>
         <p:spPr>
           <a:xfrm>
-            <a:off x="594360" y="960120"/>
-            <a:ext cx="11064240" cy="4438295"/>
+            <a:off x="411480" y="1389888"/>
+            <a:ext cx="11384280" cy="5568885"/>
           </a:xfrm>
           <a:prstGeom prst="rect">
             <a:avLst/>
           </a:prstGeom>
         </p:spPr>
       </p:pic>
-      <p:sp>
-        <p:nvSpPr>
-          <p:cNvPr id="4" name="TextBox 3"/>
-          <p:cNvSpPr txBox="1"/>
-          <p:nvPr/>
-        </p:nvSpPr>
-        <p:spPr>
-          <a:xfrm>
-            <a:off x="594360" y="6263640"/>
-            <a:ext cx="10972800" cy="502920"/>
-          </a:xfrm>
-          <a:prstGeom prst="rect">
-            <a:avLst/>
-          </a:prstGeom>
-          <a:noFill/>
-        </p:spPr>
-        <p:txBody>
-          <a:bodyPr wrap="none">
-            <a:spAutoFit/>
-          </a:bodyPr>
-          <a:lstStyle/>
-          <a:p>
-            <a:r>
-              <a:rPr sz="1100" b="0">
-                <a:solidFill>
-                  <a:srgbClr val="C8D2E1"/>
-                </a:solidFill>
-                <a:latin typeface="Times New Roman"/>
-              </a:rPr>
-              <a:t>Illustrative panels mirroring predict/explain payload keys stored in Prediction.shap_json / gradcam_json · Next.js renders bars from live API.</a:t>
-            </a:r>
-          </a:p>
-        </p:txBody>
-      </p:sp>
     </p:spTree>
   </p:cSld>
   <p:clrMapOvr>
@@ -6406,14 +5326,57 @@
       <p:grpSpPr/>
       <p:sp>
         <p:nvSpPr>
-          <p:cNvPr id="2" name="TextBox 1"/>
+          <p:cNvPr id="2" name="Rectangle 1"/>
+          <p:cNvSpPr/>
+          <p:nvPr/>
+        </p:nvSpPr>
+        <p:spPr>
+          <a:xfrm>
+            <a:off x="0" y="347472"/>
+            <a:ext cx="12191999" cy="54864"/>
+          </a:xfrm>
+          <a:prstGeom prst="rect">
+            <a:avLst/>
+          </a:prstGeom>
+          <a:solidFill>
+            <a:srgbClr val="2A9D8F"/>
+          </a:solidFill>
+          <a:ln>
+            <a:noFill/>
+          </a:ln>
+        </p:spPr>
+        <p:style>
+          <a:lnRef idx="1">
+            <a:schemeClr val="accent1"/>
+          </a:lnRef>
+          <a:fillRef idx="3">
+            <a:schemeClr val="accent1"/>
+          </a:fillRef>
+          <a:effectRef idx="2">
+            <a:schemeClr val="accent1"/>
+          </a:effectRef>
+          <a:fontRef idx="minor">
+            <a:schemeClr val="lt1"/>
+          </a:fontRef>
+        </p:style>
+        <p:txBody>
+          <a:bodyPr rtlCol="0" anchor="ctr"/>
+          <a:lstStyle/>
+          <a:p>
+            <a:pPr algn="ctr"/>
+          </a:p>
+        </p:txBody>
+      </p:sp>
+      <p:sp>
+        <p:nvSpPr>
+          <p:cNvPr id="3" name="TextBox 2"/>
           <p:cNvSpPr txBox="1"/>
           <p:nvPr/>
         </p:nvSpPr>
         <p:spPr>
           <a:xfrm>
-            <a:off x="502920" y="411480"/>
-            <a:ext cx="10972800" cy="777240"/>
+            <a:off x="502920" y="475488"/>
+            <a:ext cx="11155680" cy="822960"/>
           </a:xfrm>
           <a:prstGeom prst="rect">
             <a:avLst/>
@@ -6427,27 +5390,27 @@
           <a:lstStyle/>
           <a:p>
             <a:r>
-              <a:rPr sz="2600" b="1">
+              <a:rPr sz="2800" b="1">
                 <a:solidFill>
                   <a:srgbClr val="FFFFFF"/>
                 </a:solidFill>
                 <a:latin typeface="Times New Roman"/>
               </a:rPr>
-              <a:t>Backend API &amp; authentication</a:t>
-            </a:r>
-          </a:p>
-        </p:txBody>
-      </p:sp>
-      <p:sp>
-        <p:nvSpPr>
-          <p:cNvPr id="3" name="TextBox 2"/>
+              <a:t>FastAPI backend, Axios client &amp; auth plane</a:t>
+            </a:r>
+          </a:p>
+        </p:txBody>
+      </p:sp>
+      <p:sp>
+        <p:nvSpPr>
+          <p:cNvPr id="4" name="TextBox 3"/>
           <p:cNvSpPr txBox="1"/>
           <p:nvPr/>
         </p:nvSpPr>
         <p:spPr>
           <a:xfrm>
-            <a:off x="685800" y="1234440"/>
-            <a:ext cx="10789920" cy="5394960"/>
+            <a:off x="548640" y="987552"/>
+            <a:ext cx="10972800" cy="411480"/>
           </a:xfrm>
           <a:prstGeom prst="rect">
             <a:avLst/>
@@ -6455,108 +5418,47 @@
           <a:noFill/>
         </p:spPr>
         <p:txBody>
-          <a:bodyPr wrap="square">
+          <a:bodyPr wrap="none">
             <a:spAutoFit/>
           </a:bodyPr>
           <a:lstStyle/>
           <a:p>
-            <a:pPr>
-              <a:spcAft>
-                <a:spcPts val="1000"/>
-              </a:spcAft>
-            </a:pPr>
-            <a:r>
-              <a:rPr sz="1500" b="0">
+            <a:r>
+              <a:rPr sz="1200" b="0">
                 <a:solidFill>
-                  <a:srgbClr val="C8D2E1"/>
+                  <a:srgbClr val="C6D0E0"/>
                 </a:solidFill>
-                <a:latin typeface="Times New Roman"/>
+                <a:latin typeface="Calibri"/>
               </a:rPr>
-              <a:t>FastAPI application main.py — lifespan hooks initialise SQLite via SQLAlchemy models.</a:t>
-            </a:r>
-          </a:p>
-          <a:p>
-            <a:pPr>
-              <a:spcAft>
-                <a:spcPts val="1000"/>
-              </a:spcAft>
-            </a:pPr>
-            <a:r>
-              <a:rPr sz="1500" b="0">
-                <a:solidFill>
-                  <a:srgbClr val="C8D2E1"/>
-                </a:solidFill>
-                <a:latin typeface="Times New Roman"/>
-              </a:rPr>
-              <a:t>POST /predict · POST /predict/upload — JWT-protected; returns ami_probability, revascularization_probability, feature dicts.</a:t>
-            </a:r>
-          </a:p>
-          <a:p>
-            <a:pPr>
-              <a:spcAft>
-                <a:spcPts val="1000"/>
-              </a:spcAft>
-            </a:pPr>
-            <a:r>
-              <a:rPr sz="1500" b="0">
-                <a:solidFill>
-                  <a:srgbClr val="C8D2E1"/>
-                </a:solidFill>
-                <a:latin typeface="Times New Roman"/>
-              </a:rPr>
-              <a:t>POST /auth/register → email OTP · POST /auth/register/verify · POST /auth/login issuing Bearer JWT.</a:t>
-            </a:r>
-          </a:p>
-          <a:p>
-            <a:pPr>
-              <a:spcAft>
-                <a:spcPts val="1000"/>
-              </a:spcAft>
-            </a:pPr>
-            <a:r>
-              <a:rPr sz="1500" b="0">
-                <a:solidFill>
-                  <a:srgbClr val="C8D2E1"/>
-                </a:solidFill>
-                <a:latin typeface="Times New Roman"/>
-              </a:rPr>
-              <a:t>GET /history · GET /alerts · GET /explain/{patient_id} — authorised reads from persisted Prediction rows.</a:t>
-            </a:r>
-          </a:p>
-          <a:p>
-            <a:pPr>
-              <a:spcAft>
-                <a:spcPts val="1000"/>
-              </a:spcAft>
-            </a:pPr>
-            <a:r>
-              <a:rPr sz="1500" b="0">
-                <a:solidFill>
-                  <a:srgbClr val="C8D2E1"/>
-                </a:solidFill>
-                <a:latin typeface="Times New Roman"/>
-              </a:rPr>
-              <a:t>GET /metrics — Prometheus exposition (Counters/Histograms in metrics.py); middleware skips scrape noise.</a:t>
-            </a:r>
-          </a:p>
-          <a:p>
-            <a:pPr>
-              <a:spcAft>
-                <a:spcPts val="1000"/>
-              </a:spcAft>
-            </a:pPr>
-            <a:r>
-              <a:rPr sz="1500" b="0">
-                <a:solidFill>
-                  <a:srgbClr val="C8D2E1"/>
-                </a:solidFill>
-                <a:latin typeface="Times New Roman"/>
-              </a:rPr>
-              <a:t>GET /health — orchestration health-check used by Docker HEALTHCHECK directive.</a:t>
-            </a:r>
-          </a:p>
-        </p:txBody>
-      </p:sp>
+              <a:t>JWT + OTP registration + protected predict/history/alerts/explain routes as implemented in main.py.</a:t>
+            </a:r>
+          </a:p>
+        </p:txBody>
+      </p:sp>
+      <p:pic>
+        <p:nvPicPr>
+          <p:cNvPr id="5" name="Picture 4" descr="tmpmqckey4r.png"/>
+          <p:cNvPicPr>
+            <a:picLocks noChangeAspect="1"/>
+          </p:cNvPicPr>
+          <p:nvPr/>
+        </p:nvPicPr>
+        <p:blipFill>
+          <a:blip r:embed="rId2"/>
+          <a:stretch>
+            <a:fillRect/>
+          </a:stretch>
+        </p:blipFill>
+        <p:spPr>
+          <a:xfrm>
+            <a:off x="411480" y="1389888"/>
+            <a:ext cx="11384280" cy="5340049"/>
+          </a:xfrm>
+          <a:prstGeom prst="rect">
+            <a:avLst/>
+          </a:prstGeom>
+        </p:spPr>
+      </p:pic>
     </p:spTree>
   </p:cSld>
   <p:clrMapOvr>

</xml_diff>